<commit_message>
Presentation updated and screenshots saved
</commit_message>
<xml_diff>
--- a/4_Presentation/Group 3.pptx
+++ b/4_Presentation/Group 3.pptx
@@ -10,10 +10,15 @@
     <p:sldId id="258" r:id="rId4"/>
     <p:sldId id="259" r:id="rId5"/>
     <p:sldId id="261" r:id="rId6"/>
-    <p:sldId id="260" r:id="rId7"/>
-    <p:sldId id="262" r:id="rId8"/>
-    <p:sldId id="263" r:id="rId9"/>
-    <p:sldId id="264" r:id="rId10"/>
+    <p:sldId id="267" r:id="rId7"/>
+    <p:sldId id="268" r:id="rId8"/>
+    <p:sldId id="269" r:id="rId9"/>
+    <p:sldId id="260" r:id="rId10"/>
+    <p:sldId id="266" r:id="rId11"/>
+    <p:sldId id="263" r:id="rId12"/>
+    <p:sldId id="264" r:id="rId13"/>
+    <p:sldId id="265" r:id="rId14"/>
+    <p:sldId id="262" r:id="rId15"/>
   </p:sldIdLst>
   <p:sldSz cx="12192000" cy="6858000"/>
   <p:notesSz cx="6858000" cy="9144000"/>
@@ -112,6 +117,11 @@
       </a:defRPr>
     </a:lvl9pPr>
   </p:defaultTextStyle>
+  <p:extLst>
+    <p:ext uri="{EFAFB233-063F-42B5-8137-9DF3F51BA10A}">
+      <p15:sldGuideLst xmlns:p15="http://schemas.microsoft.com/office/powerpoint/2012/main"/>
+    </p:ext>
+  </p:extLst>
 </p:presentation>
 </file>
 
@@ -264,7 +274,7 @@
           <a:p>
             <a:fld id="{CE90F81A-5165-4AE3-BE25-017052B850AB}" type="datetimeFigureOut">
               <a:rPr lang="de-DE" smtClean="0"/>
-              <a:t>28.06.2025</a:t>
+              <a:t>29.06.2025</a:t>
             </a:fld>
             <a:endParaRPr lang="de-DE"/>
           </a:p>
@@ -318,7 +328,7 @@
           <a:p>
             <a:fld id="{FEE63D0E-FFEF-43D1-BE35-64C33AF422FD}" type="slidenum">
               <a:rPr lang="de-DE" smtClean="0"/>
-              <a:t>‹#›</a:t>
+              <a:t>‹Nr.›</a:t>
             </a:fld>
             <a:endParaRPr lang="de-DE"/>
           </a:p>
@@ -464,7 +474,7 @@
           <a:p>
             <a:fld id="{CE90F81A-5165-4AE3-BE25-017052B850AB}" type="datetimeFigureOut">
               <a:rPr lang="de-DE" smtClean="0"/>
-              <a:t>28.06.2025</a:t>
+              <a:t>29.06.2025</a:t>
             </a:fld>
             <a:endParaRPr lang="de-DE"/>
           </a:p>
@@ -518,7 +528,7 @@
           <a:p>
             <a:fld id="{FEE63D0E-FFEF-43D1-BE35-64C33AF422FD}" type="slidenum">
               <a:rPr lang="de-DE" smtClean="0"/>
-              <a:t>‹#›</a:t>
+              <a:t>‹Nr.›</a:t>
             </a:fld>
             <a:endParaRPr lang="de-DE"/>
           </a:p>
@@ -674,7 +684,7 @@
           <a:p>
             <a:fld id="{CE90F81A-5165-4AE3-BE25-017052B850AB}" type="datetimeFigureOut">
               <a:rPr lang="de-DE" smtClean="0"/>
-              <a:t>28.06.2025</a:t>
+              <a:t>29.06.2025</a:t>
             </a:fld>
             <a:endParaRPr lang="de-DE"/>
           </a:p>
@@ -728,7 +738,7 @@
           <a:p>
             <a:fld id="{FEE63D0E-FFEF-43D1-BE35-64C33AF422FD}" type="slidenum">
               <a:rPr lang="de-DE" smtClean="0"/>
-              <a:t>‹#›</a:t>
+              <a:t>‹Nr.›</a:t>
             </a:fld>
             <a:endParaRPr lang="de-DE"/>
           </a:p>
@@ -874,7 +884,7 @@
           <a:p>
             <a:fld id="{CE90F81A-5165-4AE3-BE25-017052B850AB}" type="datetimeFigureOut">
               <a:rPr lang="de-DE" smtClean="0"/>
-              <a:t>28.06.2025</a:t>
+              <a:t>29.06.2025</a:t>
             </a:fld>
             <a:endParaRPr lang="de-DE"/>
           </a:p>
@@ -928,7 +938,7 @@
           <a:p>
             <a:fld id="{FEE63D0E-FFEF-43D1-BE35-64C33AF422FD}" type="slidenum">
               <a:rPr lang="de-DE" smtClean="0"/>
-              <a:t>‹#›</a:t>
+              <a:t>‹Nr.›</a:t>
             </a:fld>
             <a:endParaRPr lang="de-DE"/>
           </a:p>
@@ -1150,7 +1160,7 @@
           <a:p>
             <a:fld id="{CE90F81A-5165-4AE3-BE25-017052B850AB}" type="datetimeFigureOut">
               <a:rPr lang="de-DE" smtClean="0"/>
-              <a:t>28.06.2025</a:t>
+              <a:t>29.06.2025</a:t>
             </a:fld>
             <a:endParaRPr lang="de-DE"/>
           </a:p>
@@ -1204,7 +1214,7 @@
           <a:p>
             <a:fld id="{FEE63D0E-FFEF-43D1-BE35-64C33AF422FD}" type="slidenum">
               <a:rPr lang="de-DE" smtClean="0"/>
-              <a:t>‹#›</a:t>
+              <a:t>‹Nr.›</a:t>
             </a:fld>
             <a:endParaRPr lang="de-DE"/>
           </a:p>
@@ -1418,7 +1428,7 @@
           <a:p>
             <a:fld id="{CE90F81A-5165-4AE3-BE25-017052B850AB}" type="datetimeFigureOut">
               <a:rPr lang="de-DE" smtClean="0"/>
-              <a:t>28.06.2025</a:t>
+              <a:t>29.06.2025</a:t>
             </a:fld>
             <a:endParaRPr lang="de-DE"/>
           </a:p>
@@ -1472,7 +1482,7 @@
           <a:p>
             <a:fld id="{FEE63D0E-FFEF-43D1-BE35-64C33AF422FD}" type="slidenum">
               <a:rPr lang="de-DE" smtClean="0"/>
-              <a:t>‹#›</a:t>
+              <a:t>‹Nr.›</a:t>
             </a:fld>
             <a:endParaRPr lang="de-DE"/>
           </a:p>
@@ -1833,7 +1843,7 @@
           <a:p>
             <a:fld id="{CE90F81A-5165-4AE3-BE25-017052B850AB}" type="datetimeFigureOut">
               <a:rPr lang="de-DE" smtClean="0"/>
-              <a:t>28.06.2025</a:t>
+              <a:t>29.06.2025</a:t>
             </a:fld>
             <a:endParaRPr lang="de-DE"/>
           </a:p>
@@ -1887,7 +1897,7 @@
           <a:p>
             <a:fld id="{FEE63D0E-FFEF-43D1-BE35-64C33AF422FD}" type="slidenum">
               <a:rPr lang="de-DE" smtClean="0"/>
-              <a:t>‹#›</a:t>
+              <a:t>‹Nr.›</a:t>
             </a:fld>
             <a:endParaRPr lang="de-DE"/>
           </a:p>
@@ -1975,7 +1985,7 @@
           <a:p>
             <a:fld id="{CE90F81A-5165-4AE3-BE25-017052B850AB}" type="datetimeFigureOut">
               <a:rPr lang="de-DE" smtClean="0"/>
-              <a:t>28.06.2025</a:t>
+              <a:t>29.06.2025</a:t>
             </a:fld>
             <a:endParaRPr lang="de-DE"/>
           </a:p>
@@ -2029,7 +2039,7 @@
           <a:p>
             <a:fld id="{FEE63D0E-FFEF-43D1-BE35-64C33AF422FD}" type="slidenum">
               <a:rPr lang="de-DE" smtClean="0"/>
-              <a:t>‹#›</a:t>
+              <a:t>‹Nr.›</a:t>
             </a:fld>
             <a:endParaRPr lang="de-DE"/>
           </a:p>
@@ -2088,7 +2098,7 @@
           <a:p>
             <a:fld id="{CE90F81A-5165-4AE3-BE25-017052B850AB}" type="datetimeFigureOut">
               <a:rPr lang="de-DE" smtClean="0"/>
-              <a:t>28.06.2025</a:t>
+              <a:t>29.06.2025</a:t>
             </a:fld>
             <a:endParaRPr lang="de-DE"/>
           </a:p>
@@ -2142,7 +2152,7 @@
           <a:p>
             <a:fld id="{FEE63D0E-FFEF-43D1-BE35-64C33AF422FD}" type="slidenum">
               <a:rPr lang="de-DE" smtClean="0"/>
-              <a:t>‹#›</a:t>
+              <a:t>‹Nr.›</a:t>
             </a:fld>
             <a:endParaRPr lang="de-DE"/>
           </a:p>
@@ -2401,7 +2411,7 @@
           <a:p>
             <a:fld id="{CE90F81A-5165-4AE3-BE25-017052B850AB}" type="datetimeFigureOut">
               <a:rPr lang="de-DE" smtClean="0"/>
-              <a:t>28.06.2025</a:t>
+              <a:t>29.06.2025</a:t>
             </a:fld>
             <a:endParaRPr lang="de-DE"/>
           </a:p>
@@ -2455,7 +2465,7 @@
           <a:p>
             <a:fld id="{FEE63D0E-FFEF-43D1-BE35-64C33AF422FD}" type="slidenum">
               <a:rPr lang="de-DE" smtClean="0"/>
-              <a:t>‹#›</a:t>
+              <a:t>‹Nr.›</a:t>
             </a:fld>
             <a:endParaRPr lang="de-DE"/>
           </a:p>
@@ -2690,7 +2700,7 @@
           <a:p>
             <a:fld id="{CE90F81A-5165-4AE3-BE25-017052B850AB}" type="datetimeFigureOut">
               <a:rPr lang="de-DE" smtClean="0"/>
-              <a:t>28.06.2025</a:t>
+              <a:t>29.06.2025</a:t>
             </a:fld>
             <a:endParaRPr lang="de-DE"/>
           </a:p>
@@ -2744,7 +2754,7 @@
           <a:p>
             <a:fld id="{FEE63D0E-FFEF-43D1-BE35-64C33AF422FD}" type="slidenum">
               <a:rPr lang="de-DE" smtClean="0"/>
-              <a:t>‹#›</a:t>
+              <a:t>‹Nr.›</a:t>
             </a:fld>
             <a:endParaRPr lang="de-DE"/>
           </a:p>
@@ -2933,7 +2943,7 @@
           <a:p>
             <a:fld id="{CE90F81A-5165-4AE3-BE25-017052B850AB}" type="datetimeFigureOut">
               <a:rPr lang="de-DE" smtClean="0"/>
-              <a:t>28.06.2025</a:t>
+              <a:t>29.06.2025</a:t>
             </a:fld>
             <a:endParaRPr lang="de-DE"/>
           </a:p>
@@ -3023,7 +3033,7 @@
           <a:p>
             <a:fld id="{FEE63D0E-FFEF-43D1-BE35-64C33AF422FD}" type="slidenum">
               <a:rPr lang="de-DE" smtClean="0"/>
-              <a:t>‹#›</a:t>
+              <a:t>‹Nr.›</a:t>
             </a:fld>
             <a:endParaRPr lang="de-DE"/>
           </a:p>
@@ -3410,6 +3420,882 @@
   <p:clrMapOvr>
     <a:masterClrMapping/>
   </p:clrMapOvr>
+  <mc:AlternateContent xmlns:mc="http://schemas.openxmlformats.org/markup-compatibility/2006">
+    <mc:Choice xmlns:p14="http://schemas.microsoft.com/office/powerpoint/2010/main" Requires="p14">
+      <p:transition spd="med" p14:dur="700">
+        <p:fade/>
+      </p:transition>
+    </mc:Choice>
+    <mc:Fallback>
+      <p:transition spd="med">
+        <p:fade/>
+      </p:transition>
+    </mc:Fallback>
+  </mc:AlternateContent>
+</p:sld>
+</file>
+
+<file path=ppt/slides/slide10.xml><?xml version="1.0" encoding="utf-8"?>
+<p:sld xmlns:a="http://schemas.openxmlformats.org/drawingml/2006/main" xmlns:r="http://schemas.openxmlformats.org/officeDocument/2006/relationships" xmlns:p="http://schemas.openxmlformats.org/presentationml/2006/main">
+  <p:cSld>
+    <p:bg>
+      <p:bgPr>
+        <a:solidFill>
+          <a:schemeClr val="bg1">
+            <a:alpha val="0"/>
+          </a:schemeClr>
+        </a:solidFill>
+        <a:effectLst/>
+      </p:bgPr>
+    </p:bg>
+    <p:spTree>
+      <p:nvGrpSpPr>
+        <p:cNvPr id="1" name="">
+          <a:extLst>
+            <a:ext uri="{FF2B5EF4-FFF2-40B4-BE49-F238E27FC236}">
+              <a16:creationId xmlns:a16="http://schemas.microsoft.com/office/drawing/2014/main" id="{3DBD1E63-5B3F-2587-2ECC-07EE6B2AF7EB}"/>
+            </a:ext>
+          </a:extLst>
+        </p:cNvPr>
+        <p:cNvGrpSpPr/>
+        <p:nvPr/>
+      </p:nvGrpSpPr>
+      <p:grpSpPr>
+        <a:xfrm>
+          <a:off x="0" y="0"/>
+          <a:ext cx="0" cy="0"/>
+          <a:chOff x="0" y="0"/>
+          <a:chExt cx="0" cy="0"/>
+        </a:xfrm>
+      </p:grpSpPr>
+      <p:pic>
+        <p:nvPicPr>
+          <p:cNvPr id="7" name="Grafik 6">
+            <a:extLst>
+              <a:ext uri="{FF2B5EF4-FFF2-40B4-BE49-F238E27FC236}">
+                <a16:creationId xmlns:a16="http://schemas.microsoft.com/office/drawing/2014/main" id="{44F6CDAE-08BF-E64C-E50F-6340BA704422}"/>
+              </a:ext>
+            </a:extLst>
+          </p:cNvPr>
+          <p:cNvPicPr>
+            <a:picLocks noChangeAspect="1"/>
+          </p:cNvPicPr>
+          <p:nvPr/>
+        </p:nvPicPr>
+        <p:blipFill>
+          <a:blip r:embed="rId2">
+            <a:extLst>
+              <a:ext uri="{28A0092B-C50C-407E-A947-70E740481C1C}">
+                <a14:useLocalDpi xmlns:a14="http://schemas.microsoft.com/office/drawing/2010/main" val="0"/>
+              </a:ext>
+            </a:extLst>
+          </a:blip>
+          <a:srcRect/>
+          <a:stretch/>
+        </p:blipFill>
+        <p:spPr>
+          <a:xfrm>
+            <a:off x="493948" y="37154"/>
+            <a:ext cx="11210371" cy="6787529"/>
+          </a:xfrm>
+          <a:prstGeom prst="rect">
+            <a:avLst/>
+          </a:prstGeom>
+        </p:spPr>
+      </p:pic>
+      <p:sp>
+        <p:nvSpPr>
+          <p:cNvPr id="4" name="TextBox 4">
+            <a:extLst>
+              <a:ext uri="{FF2B5EF4-FFF2-40B4-BE49-F238E27FC236}">
+                <a16:creationId xmlns:a16="http://schemas.microsoft.com/office/drawing/2014/main" id="{C5634A94-AF14-F23F-C63C-4A4C613B1048}"/>
+              </a:ext>
+            </a:extLst>
+          </p:cNvPr>
+          <p:cNvSpPr txBox="1"/>
+          <p:nvPr/>
+        </p:nvSpPr>
+        <p:spPr>
+          <a:xfrm>
+            <a:off x="3524719" y="6581001"/>
+            <a:ext cx="5142562" cy="276999"/>
+          </a:xfrm>
+          <a:prstGeom prst="rect">
+            <a:avLst/>
+          </a:prstGeom>
+          <a:solidFill>
+            <a:schemeClr val="bg1"/>
+          </a:solidFill>
+          <a:ln w="12700">
+            <a:solidFill>
+              <a:srgbClr val="7030A0"/>
+            </a:solidFill>
+          </a:ln>
+        </p:spPr>
+        <p:txBody>
+          <a:bodyPr wrap="none" rtlCol="0">
+            <a:spAutoFit/>
+          </a:bodyPr>
+          <a:lstStyle/>
+          <a:p>
+            <a:r>
+              <a:rPr lang="en-GB" sz="1200" dirty="0">
+                <a:solidFill>
+                  <a:schemeClr val="bg1">
+                    <a:lumMod val="75000"/>
+                  </a:schemeClr>
+                </a:solidFill>
+              </a:rPr>
+              <a:t>Dataset Characteristics </a:t>
+            </a:r>
+            <a:r>
+              <a:rPr lang="en-GB" sz="1200" dirty="0">
+                <a:solidFill>
+                  <a:schemeClr val="bg1">
+                    <a:lumMod val="75000"/>
+                  </a:schemeClr>
+                </a:solidFill>
+                <a:latin typeface="Calibri" panose="020F0502020204030204" pitchFamily="34" charset="0"/>
+                <a:ea typeface="Calibri" panose="020F0502020204030204" pitchFamily="34" charset="0"/>
+                <a:cs typeface="Calibri" panose="020F0502020204030204" pitchFamily="34" charset="0"/>
+              </a:rPr>
+              <a:t>– Baseline Model – </a:t>
+            </a:r>
+            <a:r>
+              <a:rPr lang="en-GB" sz="1200" dirty="0">
+                <a:latin typeface="Calibri" panose="020F0502020204030204" pitchFamily="34" charset="0"/>
+                <a:ea typeface="Calibri" panose="020F0502020204030204" pitchFamily="34" charset="0"/>
+                <a:cs typeface="Calibri" panose="020F0502020204030204" pitchFamily="34" charset="0"/>
+              </a:rPr>
+              <a:t>Neural Net </a:t>
+            </a:r>
+            <a:r>
+              <a:rPr lang="en-GB" sz="1200" dirty="0">
+                <a:solidFill>
+                  <a:schemeClr val="bg1">
+                    <a:lumMod val="75000"/>
+                  </a:schemeClr>
+                </a:solidFill>
+                <a:latin typeface="Calibri" panose="020F0502020204030204" pitchFamily="34" charset="0"/>
+                <a:ea typeface="Calibri" panose="020F0502020204030204" pitchFamily="34" charset="0"/>
+                <a:cs typeface="Calibri" panose="020F0502020204030204" pitchFamily="34" charset="0"/>
+              </a:rPr>
+              <a:t>– Results – Challenges </a:t>
+            </a:r>
+            <a:endParaRPr lang="de-DE" sz="1200" dirty="0">
+              <a:solidFill>
+                <a:schemeClr val="bg1">
+                  <a:lumMod val="75000"/>
+                </a:schemeClr>
+              </a:solidFill>
+            </a:endParaRPr>
+          </a:p>
+        </p:txBody>
+      </p:sp>
+    </p:spTree>
+    <p:extLst>
+      <p:ext uri="{BB962C8B-B14F-4D97-AF65-F5344CB8AC3E}">
+        <p14:creationId xmlns:p14="http://schemas.microsoft.com/office/powerpoint/2010/main" val="2699491584"/>
+      </p:ext>
+    </p:extLst>
+  </p:cSld>
+  <p:clrMapOvr>
+    <a:masterClrMapping/>
+  </p:clrMapOvr>
+  <mc:AlternateContent xmlns:mc="http://schemas.openxmlformats.org/markup-compatibility/2006">
+    <mc:Choice xmlns:p14="http://schemas.microsoft.com/office/powerpoint/2010/main" Requires="p14">
+      <p:transition spd="med" p14:dur="700">
+        <p:fade/>
+      </p:transition>
+    </mc:Choice>
+    <mc:Fallback>
+      <p:transition spd="med">
+        <p:fade/>
+      </p:transition>
+    </mc:Fallback>
+  </mc:AlternateContent>
+</p:sld>
+</file>
+
+<file path=ppt/slides/slide11.xml><?xml version="1.0" encoding="utf-8"?>
+<p:sld xmlns:a="http://schemas.openxmlformats.org/drawingml/2006/main" xmlns:r="http://schemas.openxmlformats.org/officeDocument/2006/relationships" xmlns:p="http://schemas.openxmlformats.org/presentationml/2006/main">
+  <p:cSld>
+    <p:spTree>
+      <p:nvGrpSpPr>
+        <p:cNvPr id="1" name="">
+          <a:extLst>
+            <a:ext uri="{FF2B5EF4-FFF2-40B4-BE49-F238E27FC236}">
+              <a16:creationId xmlns:a16="http://schemas.microsoft.com/office/drawing/2014/main" id="{080F9B6C-ADC8-1490-E36A-62E075121EA4}"/>
+            </a:ext>
+          </a:extLst>
+        </p:cNvPr>
+        <p:cNvGrpSpPr/>
+        <p:nvPr/>
+      </p:nvGrpSpPr>
+      <p:grpSpPr>
+        <a:xfrm>
+          <a:off x="0" y="0"/>
+          <a:ext cx="0" cy="0"/>
+          <a:chOff x="0" y="0"/>
+          <a:chExt cx="0" cy="0"/>
+        </a:xfrm>
+      </p:grpSpPr>
+      <p:pic>
+        <p:nvPicPr>
+          <p:cNvPr id="4" name="Grafik 3" descr="Ein Bild, das Text, Screenshot, Diagramm, Reihe enthält.&#10;&#10;KI-generierte Inhalte können fehlerhaft sein.">
+            <a:extLst>
+              <a:ext uri="{FF2B5EF4-FFF2-40B4-BE49-F238E27FC236}">
+                <a16:creationId xmlns:a16="http://schemas.microsoft.com/office/drawing/2014/main" id="{42986ED7-7F81-65BF-4E62-4C08801FBF9C}"/>
+              </a:ext>
+            </a:extLst>
+          </p:cNvPr>
+          <p:cNvPicPr>
+            <a:picLocks noChangeAspect="1"/>
+          </p:cNvPicPr>
+          <p:nvPr/>
+        </p:nvPicPr>
+        <p:blipFill>
+          <a:blip r:embed="rId2">
+            <a:extLst>
+              <a:ext uri="{28A0092B-C50C-407E-A947-70E740481C1C}">
+                <a14:useLocalDpi xmlns:a14="http://schemas.microsoft.com/office/drawing/2010/main" val="0"/>
+              </a:ext>
+            </a:extLst>
+          </a:blip>
+          <a:stretch>
+            <a:fillRect/>
+          </a:stretch>
+        </p:blipFill>
+        <p:spPr>
+          <a:xfrm>
+            <a:off x="456605" y="470780"/>
+            <a:ext cx="11278789" cy="5639395"/>
+          </a:xfrm>
+          <a:prstGeom prst="rect">
+            <a:avLst/>
+          </a:prstGeom>
+        </p:spPr>
+      </p:pic>
+      <p:sp>
+        <p:nvSpPr>
+          <p:cNvPr id="7" name="TextBox 4">
+            <a:extLst>
+              <a:ext uri="{FF2B5EF4-FFF2-40B4-BE49-F238E27FC236}">
+                <a16:creationId xmlns:a16="http://schemas.microsoft.com/office/drawing/2014/main" id="{53BAA4C1-94F1-F42B-C394-4865B7E235D6}"/>
+              </a:ext>
+            </a:extLst>
+          </p:cNvPr>
+          <p:cNvSpPr txBox="1"/>
+          <p:nvPr/>
+        </p:nvSpPr>
+        <p:spPr>
+          <a:xfrm>
+            <a:off x="3524719" y="6581001"/>
+            <a:ext cx="5142562" cy="276999"/>
+          </a:xfrm>
+          <a:prstGeom prst="rect">
+            <a:avLst/>
+          </a:prstGeom>
+          <a:noFill/>
+        </p:spPr>
+        <p:txBody>
+          <a:bodyPr wrap="none" rtlCol="0">
+            <a:spAutoFit/>
+          </a:bodyPr>
+          <a:lstStyle/>
+          <a:p>
+            <a:r>
+              <a:rPr lang="en-GB" sz="1200" dirty="0">
+                <a:solidFill>
+                  <a:schemeClr val="bg1">
+                    <a:lumMod val="75000"/>
+                  </a:schemeClr>
+                </a:solidFill>
+              </a:rPr>
+              <a:t>Dataset Characteristics </a:t>
+            </a:r>
+            <a:r>
+              <a:rPr lang="en-GB" sz="1200" dirty="0">
+                <a:solidFill>
+                  <a:schemeClr val="bg1">
+                    <a:lumMod val="75000"/>
+                  </a:schemeClr>
+                </a:solidFill>
+                <a:latin typeface="Calibri" panose="020F0502020204030204" pitchFamily="34" charset="0"/>
+                <a:ea typeface="Calibri" panose="020F0502020204030204" pitchFamily="34" charset="0"/>
+                <a:cs typeface="Calibri" panose="020F0502020204030204" pitchFamily="34" charset="0"/>
+              </a:rPr>
+              <a:t>– Baseline Model – </a:t>
+            </a:r>
+            <a:r>
+              <a:rPr lang="en-GB" sz="1200" dirty="0">
+                <a:latin typeface="Calibri" panose="020F0502020204030204" pitchFamily="34" charset="0"/>
+                <a:ea typeface="Calibri" panose="020F0502020204030204" pitchFamily="34" charset="0"/>
+                <a:cs typeface="Calibri" panose="020F0502020204030204" pitchFamily="34" charset="0"/>
+              </a:rPr>
+              <a:t>Neural Net </a:t>
+            </a:r>
+            <a:r>
+              <a:rPr lang="en-GB" sz="1200" dirty="0">
+                <a:solidFill>
+                  <a:schemeClr val="bg1">
+                    <a:lumMod val="75000"/>
+                  </a:schemeClr>
+                </a:solidFill>
+                <a:latin typeface="Calibri" panose="020F0502020204030204" pitchFamily="34" charset="0"/>
+                <a:ea typeface="Calibri" panose="020F0502020204030204" pitchFamily="34" charset="0"/>
+                <a:cs typeface="Calibri" panose="020F0502020204030204" pitchFamily="34" charset="0"/>
+              </a:rPr>
+              <a:t>– Results – Challenges </a:t>
+            </a:r>
+            <a:endParaRPr lang="de-DE" sz="1200" dirty="0">
+              <a:solidFill>
+                <a:schemeClr val="bg1">
+                  <a:lumMod val="75000"/>
+                </a:schemeClr>
+              </a:solidFill>
+            </a:endParaRPr>
+          </a:p>
+        </p:txBody>
+      </p:sp>
+    </p:spTree>
+    <p:extLst>
+      <p:ext uri="{BB962C8B-B14F-4D97-AF65-F5344CB8AC3E}">
+        <p14:creationId xmlns:p14="http://schemas.microsoft.com/office/powerpoint/2010/main" val="1448705476"/>
+      </p:ext>
+    </p:extLst>
+  </p:cSld>
+  <p:clrMapOvr>
+    <a:masterClrMapping/>
+  </p:clrMapOvr>
+  <mc:AlternateContent xmlns:mc="http://schemas.openxmlformats.org/markup-compatibility/2006">
+    <mc:Choice xmlns:p14="http://schemas.microsoft.com/office/powerpoint/2010/main" Requires="p14">
+      <p:transition spd="med" p14:dur="700">
+        <p:fade/>
+      </p:transition>
+    </mc:Choice>
+    <mc:Fallback>
+      <p:transition spd="med">
+        <p:fade/>
+      </p:transition>
+    </mc:Fallback>
+  </mc:AlternateContent>
+</p:sld>
+</file>
+
+<file path=ppt/slides/slide12.xml><?xml version="1.0" encoding="utf-8"?>
+<p:sld xmlns:a="http://schemas.openxmlformats.org/drawingml/2006/main" xmlns:r="http://schemas.openxmlformats.org/officeDocument/2006/relationships" xmlns:p="http://schemas.openxmlformats.org/presentationml/2006/main">
+  <p:cSld>
+    <p:spTree>
+      <p:nvGrpSpPr>
+        <p:cNvPr id="1" name="">
+          <a:extLst>
+            <a:ext uri="{FF2B5EF4-FFF2-40B4-BE49-F238E27FC236}">
+              <a16:creationId xmlns:a16="http://schemas.microsoft.com/office/drawing/2014/main" id="{05D4050B-A8AD-D44C-BDB5-DAEF0748352F}"/>
+            </a:ext>
+          </a:extLst>
+        </p:cNvPr>
+        <p:cNvGrpSpPr/>
+        <p:nvPr/>
+      </p:nvGrpSpPr>
+      <p:grpSpPr>
+        <a:xfrm>
+          <a:off x="0" y="0"/>
+          <a:ext cx="0" cy="0"/>
+          <a:chOff x="0" y="0"/>
+          <a:chExt cx="0" cy="0"/>
+        </a:xfrm>
+      </p:grpSpPr>
+      <p:sp>
+        <p:nvSpPr>
+          <p:cNvPr id="5" name="TextBox 4">
+            <a:extLst>
+              <a:ext uri="{FF2B5EF4-FFF2-40B4-BE49-F238E27FC236}">
+                <a16:creationId xmlns:a16="http://schemas.microsoft.com/office/drawing/2014/main" id="{99A00947-4782-3164-3F43-60FB01F5A96C}"/>
+              </a:ext>
+            </a:extLst>
+          </p:cNvPr>
+          <p:cNvSpPr txBox="1"/>
+          <p:nvPr/>
+        </p:nvSpPr>
+        <p:spPr>
+          <a:xfrm>
+            <a:off x="3524719" y="6581001"/>
+            <a:ext cx="5142562" cy="276999"/>
+          </a:xfrm>
+          <a:prstGeom prst="rect">
+            <a:avLst/>
+          </a:prstGeom>
+          <a:noFill/>
+        </p:spPr>
+        <p:txBody>
+          <a:bodyPr wrap="none" rtlCol="0">
+            <a:spAutoFit/>
+          </a:bodyPr>
+          <a:lstStyle/>
+          <a:p>
+            <a:r>
+              <a:rPr lang="en-GB" sz="1200" dirty="0">
+                <a:solidFill>
+                  <a:schemeClr val="bg1">
+                    <a:lumMod val="75000"/>
+                  </a:schemeClr>
+                </a:solidFill>
+              </a:rPr>
+              <a:t>Dataset Characteristics </a:t>
+            </a:r>
+            <a:r>
+              <a:rPr lang="en-GB" sz="1200" dirty="0">
+                <a:solidFill>
+                  <a:schemeClr val="bg1">
+                    <a:lumMod val="75000"/>
+                  </a:schemeClr>
+                </a:solidFill>
+                <a:latin typeface="Calibri" panose="020F0502020204030204" pitchFamily="34" charset="0"/>
+                <a:ea typeface="Calibri" panose="020F0502020204030204" pitchFamily="34" charset="0"/>
+                <a:cs typeface="Calibri" panose="020F0502020204030204" pitchFamily="34" charset="0"/>
+              </a:rPr>
+              <a:t>– Baseline Model – Neural Net – </a:t>
+            </a:r>
+            <a:r>
+              <a:rPr lang="en-GB" sz="1200" dirty="0">
+                <a:latin typeface="Calibri" panose="020F0502020204030204" pitchFamily="34" charset="0"/>
+                <a:ea typeface="Calibri" panose="020F0502020204030204" pitchFamily="34" charset="0"/>
+                <a:cs typeface="Calibri" panose="020F0502020204030204" pitchFamily="34" charset="0"/>
+              </a:rPr>
+              <a:t>Results</a:t>
+            </a:r>
+            <a:r>
+              <a:rPr lang="en-GB" sz="1200" dirty="0">
+                <a:solidFill>
+                  <a:schemeClr val="bg1">
+                    <a:lumMod val="75000"/>
+                  </a:schemeClr>
+                </a:solidFill>
+                <a:latin typeface="Calibri" panose="020F0502020204030204" pitchFamily="34" charset="0"/>
+                <a:ea typeface="Calibri" panose="020F0502020204030204" pitchFamily="34" charset="0"/>
+                <a:cs typeface="Calibri" panose="020F0502020204030204" pitchFamily="34" charset="0"/>
+              </a:rPr>
+              <a:t> – Challenges </a:t>
+            </a:r>
+            <a:endParaRPr lang="de-DE" sz="1200" dirty="0">
+              <a:solidFill>
+                <a:schemeClr val="bg1">
+                  <a:lumMod val="75000"/>
+                </a:schemeClr>
+              </a:solidFill>
+            </a:endParaRPr>
+          </a:p>
+        </p:txBody>
+      </p:sp>
+      <p:pic>
+        <p:nvPicPr>
+          <p:cNvPr id="7" name="Grafik 6" descr="Ein Bild, das Text, Screenshot, Diagramm, Reihe enthält.&#10;&#10;KI-generierte Inhalte können fehlerhaft sein.">
+            <a:extLst>
+              <a:ext uri="{FF2B5EF4-FFF2-40B4-BE49-F238E27FC236}">
+                <a16:creationId xmlns:a16="http://schemas.microsoft.com/office/drawing/2014/main" id="{EA9C2870-49A5-522B-CF9B-96A71E25A2EE}"/>
+              </a:ext>
+            </a:extLst>
+          </p:cNvPr>
+          <p:cNvPicPr>
+            <a:picLocks noChangeAspect="1"/>
+          </p:cNvPicPr>
+          <p:nvPr/>
+        </p:nvPicPr>
+        <p:blipFill>
+          <a:blip r:embed="rId2">
+            <a:extLst>
+              <a:ext uri="{28A0092B-C50C-407E-A947-70E740481C1C}">
+                <a14:useLocalDpi xmlns:a14="http://schemas.microsoft.com/office/drawing/2010/main" val="0"/>
+              </a:ext>
+            </a:extLst>
+          </a:blip>
+          <a:srcRect b="3839"/>
+          <a:stretch>
+            <a:fillRect/>
+          </a:stretch>
+        </p:blipFill>
+        <p:spPr>
+          <a:xfrm>
+            <a:off x="389487" y="-3886"/>
+            <a:ext cx="11413025" cy="6584887"/>
+          </a:xfrm>
+          <a:prstGeom prst="rect">
+            <a:avLst/>
+          </a:prstGeom>
+        </p:spPr>
+      </p:pic>
+    </p:spTree>
+    <p:extLst>
+      <p:ext uri="{BB962C8B-B14F-4D97-AF65-F5344CB8AC3E}">
+        <p14:creationId xmlns:p14="http://schemas.microsoft.com/office/powerpoint/2010/main" val="2630275565"/>
+      </p:ext>
+    </p:extLst>
+  </p:cSld>
+  <p:clrMapOvr>
+    <a:masterClrMapping/>
+  </p:clrMapOvr>
+  <mc:AlternateContent xmlns:mc="http://schemas.openxmlformats.org/markup-compatibility/2006">
+    <mc:Choice xmlns:p14="http://schemas.microsoft.com/office/powerpoint/2010/main" Requires="p14">
+      <p:transition spd="med" p14:dur="700">
+        <p:fade/>
+      </p:transition>
+    </mc:Choice>
+    <mc:Fallback>
+      <p:transition spd="med">
+        <p:fade/>
+      </p:transition>
+    </mc:Fallback>
+  </mc:AlternateContent>
+</p:sld>
+</file>
+
+<file path=ppt/slides/slide13.xml><?xml version="1.0" encoding="utf-8"?>
+<p:sld xmlns:a="http://schemas.openxmlformats.org/drawingml/2006/main" xmlns:r="http://schemas.openxmlformats.org/officeDocument/2006/relationships" xmlns:p="http://schemas.openxmlformats.org/presentationml/2006/main">
+  <p:cSld>
+    <p:spTree>
+      <p:nvGrpSpPr>
+        <p:cNvPr id="1" name="">
+          <a:extLst>
+            <a:ext uri="{FF2B5EF4-FFF2-40B4-BE49-F238E27FC236}">
+              <a16:creationId xmlns:a16="http://schemas.microsoft.com/office/drawing/2014/main" id="{03B2FF10-0B82-01EB-A019-DEB90DCFCC46}"/>
+            </a:ext>
+          </a:extLst>
+        </p:cNvPr>
+        <p:cNvGrpSpPr/>
+        <p:nvPr/>
+      </p:nvGrpSpPr>
+      <p:grpSpPr>
+        <a:xfrm>
+          <a:off x="0" y="0"/>
+          <a:ext cx="0" cy="0"/>
+          <a:chOff x="0" y="0"/>
+          <a:chExt cx="0" cy="0"/>
+        </a:xfrm>
+      </p:grpSpPr>
+      <p:sp>
+        <p:nvSpPr>
+          <p:cNvPr id="5" name="TextBox 4">
+            <a:extLst>
+              <a:ext uri="{FF2B5EF4-FFF2-40B4-BE49-F238E27FC236}">
+                <a16:creationId xmlns:a16="http://schemas.microsoft.com/office/drawing/2014/main" id="{CEA4ED14-29E3-5C36-80A2-23319535962A}"/>
+              </a:ext>
+            </a:extLst>
+          </p:cNvPr>
+          <p:cNvSpPr txBox="1"/>
+          <p:nvPr/>
+        </p:nvSpPr>
+        <p:spPr>
+          <a:xfrm>
+            <a:off x="3524719" y="6581001"/>
+            <a:ext cx="5142562" cy="276999"/>
+          </a:xfrm>
+          <a:prstGeom prst="rect">
+            <a:avLst/>
+          </a:prstGeom>
+          <a:noFill/>
+        </p:spPr>
+        <p:txBody>
+          <a:bodyPr wrap="none" rtlCol="0">
+            <a:spAutoFit/>
+          </a:bodyPr>
+          <a:lstStyle/>
+          <a:p>
+            <a:r>
+              <a:rPr lang="en-GB" sz="1200" dirty="0">
+                <a:solidFill>
+                  <a:schemeClr val="bg1">
+                    <a:lumMod val="75000"/>
+                  </a:schemeClr>
+                </a:solidFill>
+              </a:rPr>
+              <a:t>Dataset Characteristics </a:t>
+            </a:r>
+            <a:r>
+              <a:rPr lang="en-GB" sz="1200" dirty="0">
+                <a:solidFill>
+                  <a:schemeClr val="bg1">
+                    <a:lumMod val="75000"/>
+                  </a:schemeClr>
+                </a:solidFill>
+                <a:latin typeface="Calibri" panose="020F0502020204030204" pitchFamily="34" charset="0"/>
+                <a:ea typeface="Calibri" panose="020F0502020204030204" pitchFamily="34" charset="0"/>
+                <a:cs typeface="Calibri" panose="020F0502020204030204" pitchFamily="34" charset="0"/>
+              </a:rPr>
+              <a:t>– Baseline Model – Neural Net – </a:t>
+            </a:r>
+            <a:r>
+              <a:rPr lang="en-GB" sz="1200" dirty="0">
+                <a:latin typeface="Calibri" panose="020F0502020204030204" pitchFamily="34" charset="0"/>
+                <a:ea typeface="Calibri" panose="020F0502020204030204" pitchFamily="34" charset="0"/>
+                <a:cs typeface="Calibri" panose="020F0502020204030204" pitchFamily="34" charset="0"/>
+              </a:rPr>
+              <a:t>Results</a:t>
+            </a:r>
+            <a:r>
+              <a:rPr lang="en-GB" sz="1200" dirty="0">
+                <a:solidFill>
+                  <a:schemeClr val="bg1">
+                    <a:lumMod val="75000"/>
+                  </a:schemeClr>
+                </a:solidFill>
+                <a:latin typeface="Calibri" panose="020F0502020204030204" pitchFamily="34" charset="0"/>
+                <a:ea typeface="Calibri" panose="020F0502020204030204" pitchFamily="34" charset="0"/>
+                <a:cs typeface="Calibri" panose="020F0502020204030204" pitchFamily="34" charset="0"/>
+              </a:rPr>
+              <a:t> – Challenges </a:t>
+            </a:r>
+            <a:endParaRPr lang="de-DE" sz="1200" dirty="0">
+              <a:solidFill>
+                <a:schemeClr val="bg1">
+                  <a:lumMod val="75000"/>
+                </a:schemeClr>
+              </a:solidFill>
+            </a:endParaRPr>
+          </a:p>
+        </p:txBody>
+      </p:sp>
+      <p:pic>
+        <p:nvPicPr>
+          <p:cNvPr id="3" name="Grafik 2" descr="Ein Bild, das Text, Screenshot, Diagramm, Reihe enthält.&#10;&#10;KI-generierte Inhalte können fehlerhaft sein.">
+            <a:extLst>
+              <a:ext uri="{FF2B5EF4-FFF2-40B4-BE49-F238E27FC236}">
+                <a16:creationId xmlns:a16="http://schemas.microsoft.com/office/drawing/2014/main" id="{760DB1F9-1757-7989-082A-781614D707C6}"/>
+              </a:ext>
+            </a:extLst>
+          </p:cNvPr>
+          <p:cNvPicPr>
+            <a:picLocks noChangeAspect="1"/>
+          </p:cNvPicPr>
+          <p:nvPr/>
+        </p:nvPicPr>
+        <p:blipFill>
+          <a:blip r:embed="rId2">
+            <a:extLst>
+              <a:ext uri="{28A0092B-C50C-407E-A947-70E740481C1C}">
+                <a14:useLocalDpi xmlns:a14="http://schemas.microsoft.com/office/drawing/2010/main" val="0"/>
+              </a:ext>
+            </a:extLst>
+          </a:blip>
+          <a:srcRect b="3456"/>
+          <a:stretch>
+            <a:fillRect/>
+          </a:stretch>
+        </p:blipFill>
+        <p:spPr>
+          <a:xfrm>
+            <a:off x="250257" y="0"/>
+            <a:ext cx="11691486" cy="6581001"/>
+          </a:xfrm>
+          <a:prstGeom prst="rect">
+            <a:avLst/>
+          </a:prstGeom>
+        </p:spPr>
+      </p:pic>
+    </p:spTree>
+    <p:extLst>
+      <p:ext uri="{BB962C8B-B14F-4D97-AF65-F5344CB8AC3E}">
+        <p14:creationId xmlns:p14="http://schemas.microsoft.com/office/powerpoint/2010/main" val="845119171"/>
+      </p:ext>
+    </p:extLst>
+  </p:cSld>
+  <p:clrMapOvr>
+    <a:masterClrMapping/>
+  </p:clrMapOvr>
+  <mc:AlternateContent xmlns:mc="http://schemas.openxmlformats.org/markup-compatibility/2006">
+    <mc:Choice xmlns:p14="http://schemas.microsoft.com/office/powerpoint/2010/main" Requires="p14">
+      <p:transition spd="med" p14:dur="700">
+        <p:fade/>
+      </p:transition>
+    </mc:Choice>
+    <mc:Fallback>
+      <p:transition spd="med">
+        <p:fade/>
+      </p:transition>
+    </mc:Fallback>
+  </mc:AlternateContent>
+</p:sld>
+</file>
+
+<file path=ppt/slides/slide14.xml><?xml version="1.0" encoding="utf-8"?>
+<p:sld xmlns:a="http://schemas.openxmlformats.org/drawingml/2006/main" xmlns:r="http://schemas.openxmlformats.org/officeDocument/2006/relationships" xmlns:p="http://schemas.openxmlformats.org/presentationml/2006/main" show="0">
+  <p:cSld>
+    <p:bg>
+      <p:bgPr>
+        <a:solidFill>
+          <a:schemeClr val="bg1">
+            <a:alpha val="0"/>
+          </a:schemeClr>
+        </a:solidFill>
+        <a:effectLst/>
+      </p:bgPr>
+    </p:bg>
+    <p:spTree>
+      <p:nvGrpSpPr>
+        <p:cNvPr id="1" name="">
+          <a:extLst>
+            <a:ext uri="{FF2B5EF4-FFF2-40B4-BE49-F238E27FC236}">
+              <a16:creationId xmlns:a16="http://schemas.microsoft.com/office/drawing/2014/main" id="{9DF07184-045D-5BD1-0E31-4047B75F7005}"/>
+            </a:ext>
+          </a:extLst>
+        </p:cNvPr>
+        <p:cNvGrpSpPr/>
+        <p:nvPr/>
+      </p:nvGrpSpPr>
+      <p:grpSpPr>
+        <a:xfrm>
+          <a:off x="0" y="0"/>
+          <a:ext cx="0" cy="0"/>
+          <a:chOff x="0" y="0"/>
+          <a:chExt cx="0" cy="0"/>
+        </a:xfrm>
+      </p:grpSpPr>
+      <p:pic>
+        <p:nvPicPr>
+          <p:cNvPr id="7" name="Grafik 6">
+            <a:extLst>
+              <a:ext uri="{FF2B5EF4-FFF2-40B4-BE49-F238E27FC236}">
+                <a16:creationId xmlns:a16="http://schemas.microsoft.com/office/drawing/2014/main" id="{F0A034E7-CA71-E98C-AD52-B30D33186752}"/>
+              </a:ext>
+            </a:extLst>
+          </p:cNvPr>
+          <p:cNvPicPr>
+            <a:picLocks noChangeAspect="1"/>
+          </p:cNvPicPr>
+          <p:nvPr/>
+        </p:nvPicPr>
+        <p:blipFill>
+          <a:blip r:embed="rId2">
+            <a:extLst>
+              <a:ext uri="{28A0092B-C50C-407E-A947-70E740481C1C}">
+                <a14:useLocalDpi xmlns:a14="http://schemas.microsoft.com/office/drawing/2010/main" val="0"/>
+              </a:ext>
+            </a:extLst>
+          </a:blip>
+          <a:srcRect/>
+          <a:stretch/>
+        </p:blipFill>
+        <p:spPr>
+          <a:xfrm>
+            <a:off x="493948" y="0"/>
+            <a:ext cx="11210371" cy="6861838"/>
+          </a:xfrm>
+          <a:prstGeom prst="rect">
+            <a:avLst/>
+          </a:prstGeom>
+        </p:spPr>
+      </p:pic>
+      <p:sp>
+        <p:nvSpPr>
+          <p:cNvPr id="4" name="TextBox 4">
+            <a:extLst>
+              <a:ext uri="{FF2B5EF4-FFF2-40B4-BE49-F238E27FC236}">
+                <a16:creationId xmlns:a16="http://schemas.microsoft.com/office/drawing/2014/main" id="{27971549-C282-0F3B-E751-188C3029DF94}"/>
+              </a:ext>
+            </a:extLst>
+          </p:cNvPr>
+          <p:cNvSpPr txBox="1"/>
+          <p:nvPr/>
+        </p:nvSpPr>
+        <p:spPr>
+          <a:xfrm>
+            <a:off x="3524719" y="6581001"/>
+            <a:ext cx="5142562" cy="276999"/>
+          </a:xfrm>
+          <a:prstGeom prst="rect">
+            <a:avLst/>
+          </a:prstGeom>
+          <a:solidFill>
+            <a:schemeClr val="bg1"/>
+          </a:solidFill>
+          <a:ln w="12700">
+            <a:solidFill>
+              <a:srgbClr val="7030A0"/>
+            </a:solidFill>
+          </a:ln>
+        </p:spPr>
+        <p:txBody>
+          <a:bodyPr wrap="none" rtlCol="0">
+            <a:spAutoFit/>
+          </a:bodyPr>
+          <a:lstStyle/>
+          <a:p>
+            <a:r>
+              <a:rPr lang="en-GB" sz="1200" dirty="0">
+                <a:solidFill>
+                  <a:schemeClr val="bg1">
+                    <a:lumMod val="75000"/>
+                  </a:schemeClr>
+                </a:solidFill>
+              </a:rPr>
+              <a:t>Dataset Characteristics </a:t>
+            </a:r>
+            <a:r>
+              <a:rPr lang="en-GB" sz="1200" dirty="0">
+                <a:solidFill>
+                  <a:schemeClr val="bg1">
+                    <a:lumMod val="75000"/>
+                  </a:schemeClr>
+                </a:solidFill>
+                <a:latin typeface="Calibri" panose="020F0502020204030204" pitchFamily="34" charset="0"/>
+                <a:ea typeface="Calibri" panose="020F0502020204030204" pitchFamily="34" charset="0"/>
+                <a:cs typeface="Calibri" panose="020F0502020204030204" pitchFamily="34" charset="0"/>
+              </a:rPr>
+              <a:t>– Baseline Model – </a:t>
+            </a:r>
+            <a:r>
+              <a:rPr lang="en-GB" sz="1200" dirty="0">
+                <a:latin typeface="Calibri" panose="020F0502020204030204" pitchFamily="34" charset="0"/>
+                <a:ea typeface="Calibri" panose="020F0502020204030204" pitchFamily="34" charset="0"/>
+                <a:cs typeface="Calibri" panose="020F0502020204030204" pitchFamily="34" charset="0"/>
+              </a:rPr>
+              <a:t>Neural Net </a:t>
+            </a:r>
+            <a:r>
+              <a:rPr lang="en-GB" sz="1200" dirty="0">
+                <a:solidFill>
+                  <a:schemeClr val="bg1">
+                    <a:lumMod val="75000"/>
+                  </a:schemeClr>
+                </a:solidFill>
+                <a:latin typeface="Calibri" panose="020F0502020204030204" pitchFamily="34" charset="0"/>
+                <a:ea typeface="Calibri" panose="020F0502020204030204" pitchFamily="34" charset="0"/>
+                <a:cs typeface="Calibri" panose="020F0502020204030204" pitchFamily="34" charset="0"/>
+              </a:rPr>
+              <a:t>– Results – Challenges </a:t>
+            </a:r>
+            <a:endParaRPr lang="de-DE" sz="1200" dirty="0">
+              <a:solidFill>
+                <a:schemeClr val="bg1">
+                  <a:lumMod val="75000"/>
+                </a:schemeClr>
+              </a:solidFill>
+            </a:endParaRPr>
+          </a:p>
+        </p:txBody>
+      </p:sp>
+    </p:spTree>
+    <p:extLst>
+      <p:ext uri="{BB962C8B-B14F-4D97-AF65-F5344CB8AC3E}">
+        <p14:creationId xmlns:p14="http://schemas.microsoft.com/office/powerpoint/2010/main" val="1731321607"/>
+      </p:ext>
+    </p:extLst>
+  </p:cSld>
+  <p:clrMapOvr>
+    <a:masterClrMapping/>
+  </p:clrMapOvr>
+  <mc:AlternateContent xmlns:mc="http://schemas.openxmlformats.org/markup-compatibility/2006">
+    <mc:Choice xmlns:p14="http://schemas.microsoft.com/office/powerpoint/2010/main" Requires="p14">
+      <p:transition spd="med" p14:dur="700">
+        <p:fade/>
+      </p:transition>
+    </mc:Choice>
+    <mc:Fallback>
+      <p:transition spd="med">
+        <p:fade/>
+      </p:transition>
+    </mc:Fallback>
+  </mc:AlternateContent>
 </p:sld>
 </file>
 
@@ -3486,10 +4372,10 @@
       </p:sp>
       <p:sp>
         <p:nvSpPr>
-          <p:cNvPr id="5" name="TextBox 4">
-            <a:extLst>
-              <a:ext uri="{FF2B5EF4-FFF2-40B4-BE49-F238E27FC236}">
-                <a16:creationId xmlns:a16="http://schemas.microsoft.com/office/drawing/2014/main" id="{B2474956-0C2B-4D23-E369-9FFF043B6503}"/>
+          <p:cNvPr id="2" name="TextBox 4">
+            <a:extLst>
+              <a:ext uri="{FF2B5EF4-FFF2-40B4-BE49-F238E27FC236}">
+                <a16:creationId xmlns:a16="http://schemas.microsoft.com/office/drawing/2014/main" id="{7284C433-A643-362B-43A1-BEE4815EE244}"/>
               </a:ext>
             </a:extLst>
           </p:cNvPr>
@@ -3498,8 +4384,8 @@
         </p:nvSpPr>
         <p:spPr>
           <a:xfrm>
-            <a:off x="1956390" y="6488668"/>
-            <a:ext cx="7658250" cy="369332"/>
+            <a:off x="3524719" y="6581001"/>
+            <a:ext cx="5142562" cy="276999"/>
           </a:xfrm>
           <a:prstGeom prst="rect">
             <a:avLst/>
@@ -3513,19 +4399,17 @@
           <a:lstStyle/>
           <a:p>
             <a:r>
-              <a:rPr lang="en-GB" dirty="0"/>
-              <a:t>Dataset </a:t>
-            </a:r>
-            <a:r>
-              <a:rPr lang="en-GB" dirty="0" err="1"/>
-              <a:t>Characterisitcs</a:t>
-            </a:r>
-            <a:r>
-              <a:rPr lang="en-GB" dirty="0"/>
-              <a:t> </a:t>
-            </a:r>
-            <a:r>
-              <a:rPr lang="en-GB" dirty="0">
+              <a:rPr lang="en-GB" sz="1200" dirty="0">
+                <a:solidFill>
+                  <a:schemeClr val="bg1">
+                    <a:lumMod val="75000"/>
+                  </a:schemeClr>
+                </a:solidFill>
+              </a:rPr>
+              <a:t>Dataset Characteristics </a:t>
+            </a:r>
+            <a:r>
+              <a:rPr lang="en-GB" sz="1200" dirty="0">
                 <a:solidFill>
                   <a:schemeClr val="bg1">
                     <a:lumMod val="75000"/>
@@ -3535,9 +4419,30 @@
                 <a:ea typeface="Calibri" panose="020F0502020204030204" pitchFamily="34" charset="0"/>
                 <a:cs typeface="Calibri" panose="020F0502020204030204" pitchFamily="34" charset="0"/>
               </a:rPr>
-              <a:t>– Baseline Model  - Neural Net – Results - Challenges</a:t>
-            </a:r>
-            <a:endParaRPr lang="de-DE" dirty="0">
+              <a:t>– </a:t>
+            </a:r>
+            <a:r>
+              <a:rPr lang="en-GB" sz="1200" dirty="0">
+                <a:latin typeface="Calibri" panose="020F0502020204030204" pitchFamily="34" charset="0"/>
+                <a:ea typeface="Calibri" panose="020F0502020204030204" pitchFamily="34" charset="0"/>
+                <a:cs typeface="Calibri" panose="020F0502020204030204" pitchFamily="34" charset="0"/>
+              </a:rPr>
+              <a:t>Baseline Model </a:t>
+            </a:r>
+            <a:r>
+              <a:rPr lang="en-GB" sz="1200" dirty="0">
+                <a:solidFill>
+                  <a:schemeClr val="bg1">
+                    <a:lumMod val="75000"/>
+                  </a:schemeClr>
+                </a:solidFill>
+                <a:latin typeface="Calibri" panose="020F0502020204030204" pitchFamily="34" charset="0"/>
+                <a:ea typeface="Calibri" panose="020F0502020204030204" pitchFamily="34" charset="0"/>
+                <a:cs typeface="Calibri" panose="020F0502020204030204" pitchFamily="34" charset="0"/>
+              </a:rPr>
+              <a:t>– Neural Net – Results – Challenges </a:t>
+            </a:r>
+            <a:endParaRPr lang="de-DE" sz="1200" dirty="0">
               <a:solidFill>
                 <a:schemeClr val="bg1">
                   <a:lumMod val="75000"/>
@@ -3557,6 +4462,18 @@
   <p:clrMapOvr>
     <a:masterClrMapping/>
   </p:clrMapOvr>
+  <mc:AlternateContent xmlns:mc="http://schemas.openxmlformats.org/markup-compatibility/2006">
+    <mc:Choice xmlns:p14="http://schemas.microsoft.com/office/powerpoint/2010/main" Requires="p14">
+      <p:transition spd="med" p14:dur="700">
+        <p:fade/>
+      </p:transition>
+    </mc:Choice>
+    <mc:Fallback>
+      <p:transition spd="med">
+        <p:fade/>
+      </p:transition>
+    </mc:Fallback>
+  </mc:AlternateContent>
 </p:sld>
 </file>
 
@@ -3639,10 +4556,10 @@
       </p:sp>
       <p:sp>
         <p:nvSpPr>
-          <p:cNvPr id="5" name="TextBox 4">
-            <a:extLst>
-              <a:ext uri="{FF2B5EF4-FFF2-40B4-BE49-F238E27FC236}">
-                <a16:creationId xmlns:a16="http://schemas.microsoft.com/office/drawing/2014/main" id="{4968A402-3C51-5977-433A-C6146720D926}"/>
+          <p:cNvPr id="2" name="TextBox 4">
+            <a:extLst>
+              <a:ext uri="{FF2B5EF4-FFF2-40B4-BE49-F238E27FC236}">
+                <a16:creationId xmlns:a16="http://schemas.microsoft.com/office/drawing/2014/main" id="{D32F0C9B-5AD0-7CD7-5317-05DE6D327F90}"/>
               </a:ext>
             </a:extLst>
           </p:cNvPr>
@@ -3651,8 +4568,8 @@
         </p:nvSpPr>
         <p:spPr>
           <a:xfrm>
-            <a:off x="1956390" y="6488668"/>
-            <a:ext cx="7658250" cy="369332"/>
+            <a:off x="3524719" y="6581001"/>
+            <a:ext cx="5142562" cy="276999"/>
           </a:xfrm>
           <a:prstGeom prst="rect">
             <a:avLst/>
@@ -3666,19 +4583,17 @@
           <a:lstStyle/>
           <a:p>
             <a:r>
-              <a:rPr lang="en-GB" dirty="0"/>
-              <a:t>Dataset </a:t>
-            </a:r>
-            <a:r>
-              <a:rPr lang="en-GB" dirty="0" err="1"/>
-              <a:t>Characterisitcs</a:t>
-            </a:r>
-            <a:r>
-              <a:rPr lang="en-GB" dirty="0"/>
-              <a:t> </a:t>
-            </a:r>
-            <a:r>
-              <a:rPr lang="en-GB" dirty="0">
+              <a:rPr lang="en-GB" sz="1200" dirty="0">
+                <a:solidFill>
+                  <a:schemeClr val="bg1">
+                    <a:lumMod val="75000"/>
+                  </a:schemeClr>
+                </a:solidFill>
+              </a:rPr>
+              <a:t>Dataset Characteristics </a:t>
+            </a:r>
+            <a:r>
+              <a:rPr lang="en-GB" sz="1200" dirty="0">
                 <a:solidFill>
                   <a:schemeClr val="bg1">
                     <a:lumMod val="75000"/>
@@ -3688,9 +4603,30 @@
                 <a:ea typeface="Calibri" panose="020F0502020204030204" pitchFamily="34" charset="0"/>
                 <a:cs typeface="Calibri" panose="020F0502020204030204" pitchFamily="34" charset="0"/>
               </a:rPr>
-              <a:t>– Baseline Model  - Neural Net – Results - Challenges</a:t>
-            </a:r>
-            <a:endParaRPr lang="de-DE" dirty="0">
+              <a:t>– </a:t>
+            </a:r>
+            <a:r>
+              <a:rPr lang="en-GB" sz="1200" dirty="0">
+                <a:latin typeface="Calibri" panose="020F0502020204030204" pitchFamily="34" charset="0"/>
+                <a:ea typeface="Calibri" panose="020F0502020204030204" pitchFamily="34" charset="0"/>
+                <a:cs typeface="Calibri" panose="020F0502020204030204" pitchFamily="34" charset="0"/>
+              </a:rPr>
+              <a:t>Baseline Model </a:t>
+            </a:r>
+            <a:r>
+              <a:rPr lang="en-GB" sz="1200" dirty="0">
+                <a:solidFill>
+                  <a:schemeClr val="bg1">
+                    <a:lumMod val="75000"/>
+                  </a:schemeClr>
+                </a:solidFill>
+                <a:latin typeface="Calibri" panose="020F0502020204030204" pitchFamily="34" charset="0"/>
+                <a:ea typeface="Calibri" panose="020F0502020204030204" pitchFamily="34" charset="0"/>
+                <a:cs typeface="Calibri" panose="020F0502020204030204" pitchFamily="34" charset="0"/>
+              </a:rPr>
+              <a:t>– Neural Net – Results – Challenges </a:t>
+            </a:r>
+            <a:endParaRPr lang="de-DE" sz="1200" dirty="0">
               <a:solidFill>
                 <a:schemeClr val="bg1">
                   <a:lumMod val="75000"/>
@@ -3710,6 +4646,18 @@
   <p:clrMapOvr>
     <a:masterClrMapping/>
   </p:clrMapOvr>
+  <mc:AlternateContent xmlns:mc="http://schemas.openxmlformats.org/markup-compatibility/2006">
+    <mc:Choice xmlns:p14="http://schemas.microsoft.com/office/powerpoint/2010/main" Requires="p14">
+      <p:transition spd="med" p14:dur="700">
+        <p:fade/>
+      </p:transition>
+    </mc:Choice>
+    <mc:Fallback>
+      <p:transition spd="med">
+        <p:fade/>
+      </p:transition>
+    </mc:Fallback>
+  </mc:AlternateContent>
 </p:sld>
 </file>
 
@@ -3792,10 +4740,10 @@
       </p:sp>
       <p:sp>
         <p:nvSpPr>
-          <p:cNvPr id="5" name="TextBox 4">
-            <a:extLst>
-              <a:ext uri="{FF2B5EF4-FFF2-40B4-BE49-F238E27FC236}">
-                <a16:creationId xmlns:a16="http://schemas.microsoft.com/office/drawing/2014/main" id="{44DFD86E-3298-C365-6D01-4A2C6EB98EBF}"/>
+          <p:cNvPr id="2" name="TextBox 4">
+            <a:extLst>
+              <a:ext uri="{FF2B5EF4-FFF2-40B4-BE49-F238E27FC236}">
+                <a16:creationId xmlns:a16="http://schemas.microsoft.com/office/drawing/2014/main" id="{251B45FD-C30C-AA69-D916-A3EDB4DCA828}"/>
               </a:ext>
             </a:extLst>
           </p:cNvPr>
@@ -3804,8 +4752,8 @@
         </p:nvSpPr>
         <p:spPr>
           <a:xfrm>
-            <a:off x="1956390" y="6488668"/>
-            <a:ext cx="7658250" cy="369332"/>
+            <a:off x="3524719" y="6581001"/>
+            <a:ext cx="5142562" cy="276999"/>
           </a:xfrm>
           <a:prstGeom prst="rect">
             <a:avLst/>
@@ -3819,19 +4767,17 @@
           <a:lstStyle/>
           <a:p>
             <a:r>
-              <a:rPr lang="en-GB" dirty="0"/>
-              <a:t>Dataset </a:t>
-            </a:r>
-            <a:r>
-              <a:rPr lang="en-GB" dirty="0" err="1"/>
-              <a:t>Characterisitcs</a:t>
-            </a:r>
-            <a:r>
-              <a:rPr lang="en-GB" dirty="0"/>
-              <a:t> </a:t>
-            </a:r>
-            <a:r>
-              <a:rPr lang="en-GB" dirty="0">
+              <a:rPr lang="en-GB" sz="1200" dirty="0">
+                <a:solidFill>
+                  <a:schemeClr val="bg1">
+                    <a:lumMod val="75000"/>
+                  </a:schemeClr>
+                </a:solidFill>
+              </a:rPr>
+              <a:t>Dataset Characteristics </a:t>
+            </a:r>
+            <a:r>
+              <a:rPr lang="en-GB" sz="1200" dirty="0">
                 <a:solidFill>
                   <a:schemeClr val="bg1">
                     <a:lumMod val="75000"/>
@@ -3841,9 +4787,30 @@
                 <a:ea typeface="Calibri" panose="020F0502020204030204" pitchFamily="34" charset="0"/>
                 <a:cs typeface="Calibri" panose="020F0502020204030204" pitchFamily="34" charset="0"/>
               </a:rPr>
-              <a:t>– Baseline Model  - Neural Net – Results - Challenges</a:t>
-            </a:r>
-            <a:endParaRPr lang="de-DE" dirty="0">
+              <a:t>– </a:t>
+            </a:r>
+            <a:r>
+              <a:rPr lang="en-GB" sz="1200" dirty="0">
+                <a:latin typeface="Calibri" panose="020F0502020204030204" pitchFamily="34" charset="0"/>
+                <a:ea typeface="Calibri" panose="020F0502020204030204" pitchFamily="34" charset="0"/>
+                <a:cs typeface="Calibri" panose="020F0502020204030204" pitchFamily="34" charset="0"/>
+              </a:rPr>
+              <a:t>Baseline Model </a:t>
+            </a:r>
+            <a:r>
+              <a:rPr lang="en-GB" sz="1200" dirty="0">
+                <a:solidFill>
+                  <a:schemeClr val="bg1">
+                    <a:lumMod val="75000"/>
+                  </a:schemeClr>
+                </a:solidFill>
+                <a:latin typeface="Calibri" panose="020F0502020204030204" pitchFamily="34" charset="0"/>
+                <a:ea typeface="Calibri" panose="020F0502020204030204" pitchFamily="34" charset="0"/>
+                <a:cs typeface="Calibri" panose="020F0502020204030204" pitchFamily="34" charset="0"/>
+              </a:rPr>
+              <a:t>– Neural Net – Results – Challenges </a:t>
+            </a:r>
+            <a:endParaRPr lang="de-DE" sz="1200" dirty="0">
               <a:solidFill>
                 <a:schemeClr val="bg1">
                   <a:lumMod val="75000"/>
@@ -3863,6 +4830,18 @@
   <p:clrMapOvr>
     <a:masterClrMapping/>
   </p:clrMapOvr>
+  <mc:AlternateContent xmlns:mc="http://schemas.openxmlformats.org/markup-compatibility/2006">
+    <mc:Choice xmlns:p14="http://schemas.microsoft.com/office/powerpoint/2010/main" Requires="p14">
+      <p:transition spd="med" p14:dur="700">
+        <p:fade/>
+      </p:transition>
+    </mc:Choice>
+    <mc:Fallback>
+      <p:transition spd="med">
+        <p:fade/>
+      </p:transition>
+    </mc:Fallback>
+  </mc:AlternateContent>
 </p:sld>
 </file>
 
@@ -3891,10 +4870,10 @@
       </p:grpSpPr>
       <p:sp>
         <p:nvSpPr>
-          <p:cNvPr id="5" name="TextBox 4">
-            <a:extLst>
-              <a:ext uri="{FF2B5EF4-FFF2-40B4-BE49-F238E27FC236}">
-                <a16:creationId xmlns:a16="http://schemas.microsoft.com/office/drawing/2014/main" id="{7F681F1B-6249-99D2-4493-8A0C80F632F1}"/>
+          <p:cNvPr id="2" name="TextBox 4">
+            <a:extLst>
+              <a:ext uri="{FF2B5EF4-FFF2-40B4-BE49-F238E27FC236}">
+                <a16:creationId xmlns:a16="http://schemas.microsoft.com/office/drawing/2014/main" id="{C52FA7C5-2C8C-0FB1-20E6-5020C270A7A9}"/>
               </a:ext>
             </a:extLst>
           </p:cNvPr>
@@ -3903,8 +4882,8 @@
         </p:nvSpPr>
         <p:spPr>
           <a:xfrm>
-            <a:off x="1956390" y="6488668"/>
-            <a:ext cx="7658250" cy="369332"/>
+            <a:off x="3524719" y="6581001"/>
+            <a:ext cx="5142562" cy="276999"/>
           </a:xfrm>
           <a:prstGeom prst="rect">
             <a:avLst/>
@@ -3918,19 +4897,11 @@
           <a:lstStyle/>
           <a:p>
             <a:r>
-              <a:rPr lang="en-GB" dirty="0"/>
-              <a:t>Dataset </a:t>
-            </a:r>
-            <a:r>
-              <a:rPr lang="en-GB" dirty="0" err="1"/>
-              <a:t>Characterisitcs</a:t>
-            </a:r>
-            <a:r>
-              <a:rPr lang="en-GB" dirty="0"/>
-              <a:t> </a:t>
-            </a:r>
-            <a:r>
-              <a:rPr lang="en-GB" dirty="0">
+              <a:rPr lang="en-GB" sz="1200" dirty="0"/>
+              <a:t>Dataset Characteristics </a:t>
+            </a:r>
+            <a:r>
+              <a:rPr lang="en-GB" sz="1200" dirty="0">
                 <a:solidFill>
                   <a:schemeClr val="bg1">
                     <a:lumMod val="75000"/>
@@ -3940,9 +4911,9 @@
                 <a:ea typeface="Calibri" panose="020F0502020204030204" pitchFamily="34" charset="0"/>
                 <a:cs typeface="Calibri" panose="020F0502020204030204" pitchFamily="34" charset="0"/>
               </a:rPr>
-              <a:t>– Baseline Model  - Neural Net – Results - Challenges</a:t>
-            </a:r>
-            <a:endParaRPr lang="de-DE" dirty="0">
+              <a:t>– Baseline Model – Neural Net – Results – Challenges </a:t>
+            </a:r>
+            <a:endParaRPr lang="de-DE" sz="1200" dirty="0">
               <a:solidFill>
                 <a:schemeClr val="bg1">
                   <a:lumMod val="75000"/>
@@ -3954,10 +4925,10 @@
       </p:sp>
       <p:pic>
         <p:nvPicPr>
-          <p:cNvPr id="8" name="Picture 7">
-            <a:extLst>
-              <a:ext uri="{FF2B5EF4-FFF2-40B4-BE49-F238E27FC236}">
-                <a16:creationId xmlns:a16="http://schemas.microsoft.com/office/drawing/2014/main" id="{F7BCD4D6-994C-310B-85F9-BFD9F986307A}"/>
+          <p:cNvPr id="15" name="Grafik 14" descr="Ein Bild, das Text, Screenshot, parallel, Reihe enthält.&#10;&#10;KI-generierte Inhalte können fehlerhaft sein.">
+            <a:extLst>
+              <a:ext uri="{FF2B5EF4-FFF2-40B4-BE49-F238E27FC236}">
+                <a16:creationId xmlns:a16="http://schemas.microsoft.com/office/drawing/2014/main" id="{34505F1F-E139-8D93-4BB1-701B4A3A66E8}"/>
               </a:ext>
             </a:extLst>
           </p:cNvPr>
@@ -3974,51 +4945,14 @@
               </a:ext>
             </a:extLst>
           </a:blip>
-          <a:srcRect/>
-          <a:stretch/>
+          <a:stretch>
+            <a:fillRect/>
+          </a:stretch>
         </p:blipFill>
         <p:spPr>
           <a:xfrm>
-            <a:off x="1884556" y="-680207"/>
-            <a:ext cx="9439507" cy="7317583"/>
-          </a:xfrm>
-          <a:prstGeom prst="rect">
-            <a:avLst/>
-          </a:prstGeom>
-          <a:ln w="19050">
-            <a:noFill/>
-          </a:ln>
-        </p:spPr>
-      </p:pic>
-      <p:pic>
-        <p:nvPicPr>
-          <p:cNvPr id="10" name="Picture 9">
-            <a:extLst>
-              <a:ext uri="{FF2B5EF4-FFF2-40B4-BE49-F238E27FC236}">
-                <a16:creationId xmlns:a16="http://schemas.microsoft.com/office/drawing/2014/main" id="{4B70DF3E-0458-94D9-7D2D-DC7701FDB57D}"/>
-              </a:ext>
-            </a:extLst>
-          </p:cNvPr>
-          <p:cNvPicPr>
-            <a:picLocks noChangeAspect="1"/>
-          </p:cNvPicPr>
-          <p:nvPr/>
-        </p:nvPicPr>
-        <p:blipFill>
-          <a:blip r:embed="rId3">
-            <a:extLst>
-              <a:ext uri="{28A0092B-C50C-407E-A947-70E740481C1C}">
-                <a14:useLocalDpi xmlns:a14="http://schemas.microsoft.com/office/drawing/2010/main" val="0"/>
-              </a:ext>
-            </a:extLst>
-          </a:blip>
-          <a:srcRect/>
-          <a:stretch/>
-        </p:blipFill>
-        <p:spPr>
-          <a:xfrm>
-            <a:off x="370358" y="140530"/>
-            <a:ext cx="9757541" cy="6271404"/>
+            <a:off x="946653" y="0"/>
+            <a:ext cx="10298694" cy="6619216"/>
           </a:xfrm>
           <a:prstGeom prst="rect">
             <a:avLst/>
@@ -4035,6 +4969,639 @@
   <p:clrMapOvr>
     <a:masterClrMapping/>
   </p:clrMapOvr>
+  <mc:AlternateContent xmlns:mc="http://schemas.openxmlformats.org/markup-compatibility/2006">
+    <mc:Choice xmlns:p14="http://schemas.microsoft.com/office/powerpoint/2010/main" Requires="p14">
+      <p:transition spd="med" p14:dur="700">
+        <p:fade/>
+      </p:transition>
+    </mc:Choice>
+    <mc:Fallback>
+      <p:transition spd="med">
+        <p:fade/>
+      </p:transition>
+    </mc:Fallback>
+  </mc:AlternateContent>
+</p:sld>
+</file>
+
+<file path=ppt/slides/slide6.xml><?xml version="1.0" encoding="utf-8"?>
+<p:sld xmlns:a="http://schemas.openxmlformats.org/drawingml/2006/main" xmlns:r="http://schemas.openxmlformats.org/officeDocument/2006/relationships" xmlns:p="http://schemas.openxmlformats.org/presentationml/2006/main">
+  <p:cSld>
+    <p:spTree>
+      <p:nvGrpSpPr>
+        <p:cNvPr id="1" name="">
+          <a:extLst>
+            <a:ext uri="{FF2B5EF4-FFF2-40B4-BE49-F238E27FC236}">
+              <a16:creationId xmlns:a16="http://schemas.microsoft.com/office/drawing/2014/main" id="{19BA4A2B-A563-8D25-F91D-B6DE7CF03D39}"/>
+            </a:ext>
+          </a:extLst>
+        </p:cNvPr>
+        <p:cNvGrpSpPr/>
+        <p:nvPr/>
+      </p:nvGrpSpPr>
+      <p:grpSpPr>
+        <a:xfrm>
+          <a:off x="0" y="0"/>
+          <a:ext cx="0" cy="0"/>
+          <a:chOff x="0" y="0"/>
+          <a:chExt cx="0" cy="0"/>
+        </a:xfrm>
+      </p:grpSpPr>
+      <p:sp>
+        <p:nvSpPr>
+          <p:cNvPr id="2" name="TextBox 4">
+            <a:extLst>
+              <a:ext uri="{FF2B5EF4-FFF2-40B4-BE49-F238E27FC236}">
+                <a16:creationId xmlns:a16="http://schemas.microsoft.com/office/drawing/2014/main" id="{0C0CFE69-0BC5-10DD-F40C-9F5B47C9DB68}"/>
+              </a:ext>
+            </a:extLst>
+          </p:cNvPr>
+          <p:cNvSpPr txBox="1"/>
+          <p:nvPr/>
+        </p:nvSpPr>
+        <p:spPr>
+          <a:xfrm>
+            <a:off x="3524719" y="6581001"/>
+            <a:ext cx="5142562" cy="276999"/>
+          </a:xfrm>
+          <a:prstGeom prst="rect">
+            <a:avLst/>
+          </a:prstGeom>
+          <a:noFill/>
+        </p:spPr>
+        <p:txBody>
+          <a:bodyPr wrap="none" rtlCol="0">
+            <a:spAutoFit/>
+          </a:bodyPr>
+          <a:lstStyle/>
+          <a:p>
+            <a:r>
+              <a:rPr lang="en-GB" sz="1200" dirty="0"/>
+              <a:t>Dataset Characteristics </a:t>
+            </a:r>
+            <a:r>
+              <a:rPr lang="en-GB" sz="1200" dirty="0">
+                <a:solidFill>
+                  <a:schemeClr val="bg1">
+                    <a:lumMod val="75000"/>
+                  </a:schemeClr>
+                </a:solidFill>
+                <a:latin typeface="Calibri" panose="020F0502020204030204" pitchFamily="34" charset="0"/>
+                <a:ea typeface="Calibri" panose="020F0502020204030204" pitchFamily="34" charset="0"/>
+                <a:cs typeface="Calibri" panose="020F0502020204030204" pitchFamily="34" charset="0"/>
+              </a:rPr>
+              <a:t>– Baseline Model – Neural Net – Results – Challenges </a:t>
+            </a:r>
+            <a:endParaRPr lang="de-DE" sz="1200" dirty="0">
+              <a:solidFill>
+                <a:schemeClr val="bg1">
+                  <a:lumMod val="75000"/>
+                </a:schemeClr>
+              </a:solidFill>
+            </a:endParaRPr>
+          </a:p>
+        </p:txBody>
+      </p:sp>
+      <p:pic>
+        <p:nvPicPr>
+          <p:cNvPr id="15" name="Grafik 14">
+            <a:extLst>
+              <a:ext uri="{FF2B5EF4-FFF2-40B4-BE49-F238E27FC236}">
+                <a16:creationId xmlns:a16="http://schemas.microsoft.com/office/drawing/2014/main" id="{74329CC1-3E24-3DC9-0709-E6D9815CDA4A}"/>
+              </a:ext>
+            </a:extLst>
+          </p:cNvPr>
+          <p:cNvPicPr>
+            <a:picLocks noChangeAspect="1"/>
+          </p:cNvPicPr>
+          <p:nvPr/>
+        </p:nvPicPr>
+        <p:blipFill>
+          <a:blip r:embed="rId2">
+            <a:extLst>
+              <a:ext uri="{28A0092B-C50C-407E-A947-70E740481C1C}">
+                <a14:useLocalDpi xmlns:a14="http://schemas.microsoft.com/office/drawing/2010/main" val="0"/>
+              </a:ext>
+            </a:extLst>
+          </a:blip>
+          <a:srcRect/>
+          <a:stretch/>
+        </p:blipFill>
+        <p:spPr>
+          <a:xfrm>
+            <a:off x="946653" y="66555"/>
+            <a:ext cx="10298694" cy="6486105"/>
+          </a:xfrm>
+          <a:prstGeom prst="rect">
+            <a:avLst/>
+          </a:prstGeom>
+        </p:spPr>
+      </p:pic>
+    </p:spTree>
+    <p:extLst>
+      <p:ext uri="{BB962C8B-B14F-4D97-AF65-F5344CB8AC3E}">
+        <p14:creationId xmlns:p14="http://schemas.microsoft.com/office/powerpoint/2010/main" val="480653654"/>
+      </p:ext>
+    </p:extLst>
+  </p:cSld>
+  <p:clrMapOvr>
+    <a:masterClrMapping/>
+  </p:clrMapOvr>
+  <mc:AlternateContent xmlns:mc="http://schemas.openxmlformats.org/markup-compatibility/2006">
+    <mc:Choice xmlns:p14="http://schemas.microsoft.com/office/powerpoint/2010/main" Requires="p14">
+      <p:transition spd="med" p14:dur="700">
+        <p:fade/>
+      </p:transition>
+    </mc:Choice>
+    <mc:Fallback>
+      <p:transition spd="med">
+        <p:fade/>
+      </p:transition>
+    </mc:Fallback>
+  </mc:AlternateContent>
+</p:sld>
+</file>
+
+<file path=ppt/slides/slide7.xml><?xml version="1.0" encoding="utf-8"?>
+<p:sld xmlns:a="http://schemas.openxmlformats.org/drawingml/2006/main" xmlns:r="http://schemas.openxmlformats.org/officeDocument/2006/relationships" xmlns:p="http://schemas.openxmlformats.org/presentationml/2006/main">
+  <p:cSld>
+    <p:spTree>
+      <p:nvGrpSpPr>
+        <p:cNvPr id="1" name="">
+          <a:extLst>
+            <a:ext uri="{FF2B5EF4-FFF2-40B4-BE49-F238E27FC236}">
+              <a16:creationId xmlns:a16="http://schemas.microsoft.com/office/drawing/2014/main" id="{5A2B9FEE-4B08-6D63-A4FF-795B22CCFECF}"/>
+            </a:ext>
+          </a:extLst>
+        </p:cNvPr>
+        <p:cNvGrpSpPr/>
+        <p:nvPr/>
+      </p:nvGrpSpPr>
+      <p:grpSpPr>
+        <a:xfrm>
+          <a:off x="0" y="0"/>
+          <a:ext cx="0" cy="0"/>
+          <a:chOff x="0" y="0"/>
+          <a:chExt cx="0" cy="0"/>
+        </a:xfrm>
+      </p:grpSpPr>
+      <p:sp>
+        <p:nvSpPr>
+          <p:cNvPr id="2" name="TextBox 4">
+            <a:extLst>
+              <a:ext uri="{FF2B5EF4-FFF2-40B4-BE49-F238E27FC236}">
+                <a16:creationId xmlns:a16="http://schemas.microsoft.com/office/drawing/2014/main" id="{861558DA-2C5D-8E45-448B-CFFE926B267E}"/>
+              </a:ext>
+            </a:extLst>
+          </p:cNvPr>
+          <p:cNvSpPr txBox="1"/>
+          <p:nvPr/>
+        </p:nvSpPr>
+        <p:spPr>
+          <a:xfrm>
+            <a:off x="3524719" y="6581001"/>
+            <a:ext cx="5142562" cy="276999"/>
+          </a:xfrm>
+          <a:prstGeom prst="rect">
+            <a:avLst/>
+          </a:prstGeom>
+          <a:noFill/>
+        </p:spPr>
+        <p:txBody>
+          <a:bodyPr wrap="none" rtlCol="0">
+            <a:spAutoFit/>
+          </a:bodyPr>
+          <a:lstStyle/>
+          <a:p>
+            <a:r>
+              <a:rPr lang="en-GB" sz="1200" dirty="0"/>
+              <a:t>Dataset Characteristics </a:t>
+            </a:r>
+            <a:r>
+              <a:rPr lang="en-GB" sz="1200" dirty="0">
+                <a:solidFill>
+                  <a:schemeClr val="bg1">
+                    <a:lumMod val="75000"/>
+                  </a:schemeClr>
+                </a:solidFill>
+                <a:latin typeface="Calibri" panose="020F0502020204030204" pitchFamily="34" charset="0"/>
+                <a:ea typeface="Calibri" panose="020F0502020204030204" pitchFamily="34" charset="0"/>
+                <a:cs typeface="Calibri" panose="020F0502020204030204" pitchFamily="34" charset="0"/>
+              </a:rPr>
+              <a:t>– Baseline Model – Neural Net – Results – Challenges </a:t>
+            </a:r>
+            <a:endParaRPr lang="de-DE" sz="1200" dirty="0">
+              <a:solidFill>
+                <a:schemeClr val="bg1">
+                  <a:lumMod val="75000"/>
+                </a:schemeClr>
+              </a:solidFill>
+            </a:endParaRPr>
+          </a:p>
+        </p:txBody>
+      </p:sp>
+      <p:pic>
+        <p:nvPicPr>
+          <p:cNvPr id="15" name="Grafik 14">
+            <a:extLst>
+              <a:ext uri="{FF2B5EF4-FFF2-40B4-BE49-F238E27FC236}">
+                <a16:creationId xmlns:a16="http://schemas.microsoft.com/office/drawing/2014/main" id="{363918E8-E9CF-0F0E-2A7E-23840F8B1020}"/>
+              </a:ext>
+            </a:extLst>
+          </p:cNvPr>
+          <p:cNvPicPr>
+            <a:picLocks noChangeAspect="1"/>
+          </p:cNvPicPr>
+          <p:nvPr/>
+        </p:nvPicPr>
+        <p:blipFill>
+          <a:blip r:embed="rId2">
+            <a:extLst>
+              <a:ext uri="{28A0092B-C50C-407E-A947-70E740481C1C}">
+                <a14:useLocalDpi xmlns:a14="http://schemas.microsoft.com/office/drawing/2010/main" val="0"/>
+              </a:ext>
+            </a:extLst>
+          </a:blip>
+          <a:srcRect/>
+          <a:stretch/>
+        </p:blipFill>
+        <p:spPr>
+          <a:xfrm>
+            <a:off x="1156670" y="66555"/>
+            <a:ext cx="9878660" cy="6486105"/>
+          </a:xfrm>
+          <a:prstGeom prst="rect">
+            <a:avLst/>
+          </a:prstGeom>
+        </p:spPr>
+      </p:pic>
+    </p:spTree>
+    <p:extLst>
+      <p:ext uri="{BB962C8B-B14F-4D97-AF65-F5344CB8AC3E}">
+        <p14:creationId xmlns:p14="http://schemas.microsoft.com/office/powerpoint/2010/main" val="571893914"/>
+      </p:ext>
+    </p:extLst>
+  </p:cSld>
+  <p:clrMapOvr>
+    <a:masterClrMapping/>
+  </p:clrMapOvr>
+  <mc:AlternateContent xmlns:mc="http://schemas.openxmlformats.org/markup-compatibility/2006">
+    <mc:Choice xmlns:p14="http://schemas.microsoft.com/office/powerpoint/2010/main" Requires="p14">
+      <p:transition spd="med" p14:dur="700">
+        <p:fade/>
+      </p:transition>
+    </mc:Choice>
+    <mc:Fallback>
+      <p:transition spd="med">
+        <p:fade/>
+      </p:transition>
+    </mc:Fallback>
+  </mc:AlternateContent>
+</p:sld>
+</file>
+
+<file path=ppt/slides/slide8.xml><?xml version="1.0" encoding="utf-8"?>
+<p:sld xmlns:a="http://schemas.openxmlformats.org/drawingml/2006/main" xmlns:r="http://schemas.openxmlformats.org/officeDocument/2006/relationships" xmlns:p="http://schemas.openxmlformats.org/presentationml/2006/main">
+  <p:cSld>
+    <p:spTree>
+      <p:nvGrpSpPr>
+        <p:cNvPr id="1" name="">
+          <a:extLst>
+            <a:ext uri="{FF2B5EF4-FFF2-40B4-BE49-F238E27FC236}">
+              <a16:creationId xmlns:a16="http://schemas.microsoft.com/office/drawing/2014/main" id="{DB45A4B5-0372-3F67-AC94-F9B608C8F329}"/>
+            </a:ext>
+          </a:extLst>
+        </p:cNvPr>
+        <p:cNvGrpSpPr/>
+        <p:nvPr/>
+      </p:nvGrpSpPr>
+      <p:grpSpPr>
+        <a:xfrm>
+          <a:off x="0" y="0"/>
+          <a:ext cx="0" cy="0"/>
+          <a:chOff x="0" y="0"/>
+          <a:chExt cx="0" cy="0"/>
+        </a:xfrm>
+      </p:grpSpPr>
+      <p:sp>
+        <p:nvSpPr>
+          <p:cNvPr id="2" name="TextBox 4">
+            <a:extLst>
+              <a:ext uri="{FF2B5EF4-FFF2-40B4-BE49-F238E27FC236}">
+                <a16:creationId xmlns:a16="http://schemas.microsoft.com/office/drawing/2014/main" id="{E7BCC090-C36A-89F7-6166-983AA319B98C}"/>
+              </a:ext>
+            </a:extLst>
+          </p:cNvPr>
+          <p:cNvSpPr txBox="1"/>
+          <p:nvPr/>
+        </p:nvSpPr>
+        <p:spPr>
+          <a:xfrm>
+            <a:off x="3524719" y="6581001"/>
+            <a:ext cx="5142562" cy="276999"/>
+          </a:xfrm>
+          <a:prstGeom prst="rect">
+            <a:avLst/>
+          </a:prstGeom>
+          <a:noFill/>
+        </p:spPr>
+        <p:txBody>
+          <a:bodyPr wrap="none" rtlCol="0">
+            <a:spAutoFit/>
+          </a:bodyPr>
+          <a:lstStyle/>
+          <a:p>
+            <a:r>
+              <a:rPr lang="en-GB" sz="1200" dirty="0"/>
+              <a:t>Dataset Characteristics </a:t>
+            </a:r>
+            <a:r>
+              <a:rPr lang="en-GB" sz="1200" dirty="0">
+                <a:solidFill>
+                  <a:schemeClr val="bg1">
+                    <a:lumMod val="75000"/>
+                  </a:schemeClr>
+                </a:solidFill>
+                <a:latin typeface="Calibri" panose="020F0502020204030204" pitchFamily="34" charset="0"/>
+                <a:ea typeface="Calibri" panose="020F0502020204030204" pitchFamily="34" charset="0"/>
+                <a:cs typeface="Calibri" panose="020F0502020204030204" pitchFamily="34" charset="0"/>
+              </a:rPr>
+              <a:t>– Baseline Model – Neural Net – Results – Challenges </a:t>
+            </a:r>
+            <a:endParaRPr lang="de-DE" sz="1200" dirty="0">
+              <a:solidFill>
+                <a:schemeClr val="bg1">
+                  <a:lumMod val="75000"/>
+                </a:schemeClr>
+              </a:solidFill>
+            </a:endParaRPr>
+          </a:p>
+        </p:txBody>
+      </p:sp>
+      <p:pic>
+        <p:nvPicPr>
+          <p:cNvPr id="15" name="Grafik 14">
+            <a:extLst>
+              <a:ext uri="{FF2B5EF4-FFF2-40B4-BE49-F238E27FC236}">
+                <a16:creationId xmlns:a16="http://schemas.microsoft.com/office/drawing/2014/main" id="{D65F4FD0-79E5-DD61-39EE-6E078DDBB00D}"/>
+              </a:ext>
+            </a:extLst>
+          </p:cNvPr>
+          <p:cNvPicPr>
+            <a:picLocks noChangeAspect="1"/>
+          </p:cNvPicPr>
+          <p:nvPr/>
+        </p:nvPicPr>
+        <p:blipFill>
+          <a:blip r:embed="rId2">
+            <a:extLst>
+              <a:ext uri="{28A0092B-C50C-407E-A947-70E740481C1C}">
+                <a14:useLocalDpi xmlns:a14="http://schemas.microsoft.com/office/drawing/2010/main" val="0"/>
+              </a:ext>
+            </a:extLst>
+          </a:blip>
+          <a:srcRect/>
+          <a:stretch/>
+        </p:blipFill>
+        <p:spPr>
+          <a:xfrm>
+            <a:off x="908911" y="0"/>
+            <a:ext cx="10374177" cy="6612217"/>
+          </a:xfrm>
+          <a:prstGeom prst="rect">
+            <a:avLst/>
+          </a:prstGeom>
+        </p:spPr>
+      </p:pic>
+    </p:spTree>
+    <p:extLst>
+      <p:ext uri="{BB962C8B-B14F-4D97-AF65-F5344CB8AC3E}">
+        <p14:creationId xmlns:p14="http://schemas.microsoft.com/office/powerpoint/2010/main" val="1854528685"/>
+      </p:ext>
+    </p:extLst>
+  </p:cSld>
+  <p:clrMapOvr>
+    <a:masterClrMapping/>
+  </p:clrMapOvr>
+  <mc:AlternateContent xmlns:mc="http://schemas.openxmlformats.org/markup-compatibility/2006">
+    <mc:Choice xmlns:p14="http://schemas.microsoft.com/office/powerpoint/2010/main" Requires="p14">
+      <p:transition spd="med" p14:dur="700">
+        <p:fade/>
+      </p:transition>
+    </mc:Choice>
+    <mc:Fallback>
+      <p:transition spd="med">
+        <p:fade/>
+      </p:transition>
+    </mc:Fallback>
+  </mc:AlternateContent>
+</p:sld>
+</file>
+
+<file path=ppt/slides/slide9.xml><?xml version="1.0" encoding="utf-8"?>
+<p:sld xmlns:a="http://schemas.openxmlformats.org/drawingml/2006/main" xmlns:r="http://schemas.openxmlformats.org/officeDocument/2006/relationships" xmlns:p="http://schemas.openxmlformats.org/presentationml/2006/main">
+  <p:cSld>
+    <p:spTree>
+      <p:nvGrpSpPr>
+        <p:cNvPr id="1" name="">
+          <a:extLst>
+            <a:ext uri="{FF2B5EF4-FFF2-40B4-BE49-F238E27FC236}">
+              <a16:creationId xmlns:a16="http://schemas.microsoft.com/office/drawing/2014/main" id="{ACAFECE9-6D9E-9E37-8E1A-D2A31B44E809}"/>
+            </a:ext>
+          </a:extLst>
+        </p:cNvPr>
+        <p:cNvGrpSpPr/>
+        <p:nvPr/>
+      </p:nvGrpSpPr>
+      <p:grpSpPr>
+        <a:xfrm>
+          <a:off x="0" y="0"/>
+          <a:ext cx="0" cy="0"/>
+          <a:chOff x="0" y="0"/>
+          <a:chExt cx="0" cy="0"/>
+        </a:xfrm>
+      </p:grpSpPr>
+      <p:pic>
+        <p:nvPicPr>
+          <p:cNvPr id="8" name="Picture 7" descr="A screenshot of a computer&#10;&#10;AI-generated content may be incorrect.">
+            <a:extLst>
+              <a:ext uri="{FF2B5EF4-FFF2-40B4-BE49-F238E27FC236}">
+                <a16:creationId xmlns:a16="http://schemas.microsoft.com/office/drawing/2014/main" id="{826FC09F-B539-64E9-5BFB-2E19E12C3B3E}"/>
+              </a:ext>
+            </a:extLst>
+          </p:cNvPr>
+          <p:cNvPicPr>
+            <a:picLocks noChangeAspect="1"/>
+          </p:cNvPicPr>
+          <p:nvPr/>
+        </p:nvPicPr>
+        <p:blipFill>
+          <a:blip r:embed="rId2">
+            <a:extLst>
+              <a:ext uri="{28A0092B-C50C-407E-A947-70E740481C1C}">
+                <a14:useLocalDpi xmlns:a14="http://schemas.microsoft.com/office/drawing/2010/main" val="0"/>
+              </a:ext>
+            </a:extLst>
+          </a:blip>
+          <a:stretch>
+            <a:fillRect/>
+          </a:stretch>
+        </p:blipFill>
+        <p:spPr>
+          <a:xfrm>
+            <a:off x="1613129" y="2057399"/>
+            <a:ext cx="8813341" cy="2748605"/>
+          </a:xfrm>
+          <a:prstGeom prst="rect">
+            <a:avLst/>
+          </a:prstGeom>
+          <a:ln w="19050">
+            <a:solidFill>
+              <a:schemeClr val="tx1"/>
+            </a:solidFill>
+          </a:ln>
+        </p:spPr>
+      </p:pic>
+      <p:pic>
+        <p:nvPicPr>
+          <p:cNvPr id="10" name="Picture 9" descr="A screenshot of a document&#10;&#10;AI-generated content may be incorrect.">
+            <a:extLst>
+              <a:ext uri="{FF2B5EF4-FFF2-40B4-BE49-F238E27FC236}">
+                <a16:creationId xmlns:a16="http://schemas.microsoft.com/office/drawing/2014/main" id="{A8BF8A03-866A-5220-CC7A-B17CC0387014}"/>
+              </a:ext>
+            </a:extLst>
+          </p:cNvPr>
+          <p:cNvPicPr>
+            <a:picLocks noChangeAspect="1"/>
+          </p:cNvPicPr>
+          <p:nvPr/>
+        </p:nvPicPr>
+        <p:blipFill>
+          <a:blip r:embed="rId3">
+            <a:extLst>
+              <a:ext uri="{28A0092B-C50C-407E-A947-70E740481C1C}">
+                <a14:useLocalDpi xmlns:a14="http://schemas.microsoft.com/office/drawing/2010/main" val="0"/>
+              </a:ext>
+            </a:extLst>
+          </a:blip>
+          <a:stretch>
+            <a:fillRect/>
+          </a:stretch>
+        </p:blipFill>
+        <p:spPr>
+          <a:xfrm>
+            <a:off x="986659" y="0"/>
+            <a:ext cx="9671823" cy="6481981"/>
+          </a:xfrm>
+          <a:prstGeom prst="rect">
+            <a:avLst/>
+          </a:prstGeom>
+        </p:spPr>
+      </p:pic>
+      <p:sp>
+        <p:nvSpPr>
+          <p:cNvPr id="3" name="TextBox 4">
+            <a:extLst>
+              <a:ext uri="{FF2B5EF4-FFF2-40B4-BE49-F238E27FC236}">
+                <a16:creationId xmlns:a16="http://schemas.microsoft.com/office/drawing/2014/main" id="{AA969668-41C2-2371-36BB-952A209FC55C}"/>
+              </a:ext>
+            </a:extLst>
+          </p:cNvPr>
+          <p:cNvSpPr txBox="1"/>
+          <p:nvPr/>
+        </p:nvSpPr>
+        <p:spPr>
+          <a:xfrm>
+            <a:off x="3524719" y="6581001"/>
+            <a:ext cx="5142562" cy="276999"/>
+          </a:xfrm>
+          <a:prstGeom prst="rect">
+            <a:avLst/>
+          </a:prstGeom>
+          <a:noFill/>
+        </p:spPr>
+        <p:txBody>
+          <a:bodyPr wrap="none" rtlCol="0">
+            <a:spAutoFit/>
+          </a:bodyPr>
+          <a:lstStyle/>
+          <a:p>
+            <a:r>
+              <a:rPr lang="en-GB" sz="1200" dirty="0">
+                <a:solidFill>
+                  <a:schemeClr val="bg1">
+                    <a:lumMod val="75000"/>
+                  </a:schemeClr>
+                </a:solidFill>
+              </a:rPr>
+              <a:t>Dataset Characteristics </a:t>
+            </a:r>
+            <a:r>
+              <a:rPr lang="en-GB" sz="1200" dirty="0">
+                <a:solidFill>
+                  <a:schemeClr val="bg1">
+                    <a:lumMod val="75000"/>
+                  </a:schemeClr>
+                </a:solidFill>
+                <a:latin typeface="Calibri" panose="020F0502020204030204" pitchFamily="34" charset="0"/>
+                <a:ea typeface="Calibri" panose="020F0502020204030204" pitchFamily="34" charset="0"/>
+                <a:cs typeface="Calibri" panose="020F0502020204030204" pitchFamily="34" charset="0"/>
+              </a:rPr>
+              <a:t>– </a:t>
+            </a:r>
+            <a:r>
+              <a:rPr lang="en-GB" sz="1200" dirty="0">
+                <a:latin typeface="Calibri" panose="020F0502020204030204" pitchFamily="34" charset="0"/>
+                <a:ea typeface="Calibri" panose="020F0502020204030204" pitchFamily="34" charset="0"/>
+                <a:cs typeface="Calibri" panose="020F0502020204030204" pitchFamily="34" charset="0"/>
+              </a:rPr>
+              <a:t>Baseline Model </a:t>
+            </a:r>
+            <a:r>
+              <a:rPr lang="en-GB" sz="1200" dirty="0">
+                <a:solidFill>
+                  <a:schemeClr val="bg1">
+                    <a:lumMod val="75000"/>
+                  </a:schemeClr>
+                </a:solidFill>
+                <a:latin typeface="Calibri" panose="020F0502020204030204" pitchFamily="34" charset="0"/>
+                <a:ea typeface="Calibri" panose="020F0502020204030204" pitchFamily="34" charset="0"/>
+                <a:cs typeface="Calibri" panose="020F0502020204030204" pitchFamily="34" charset="0"/>
+              </a:rPr>
+              <a:t>– Neural Net – Results – Challenges </a:t>
+            </a:r>
+            <a:endParaRPr lang="de-DE" sz="1200" dirty="0">
+              <a:solidFill>
+                <a:schemeClr val="bg1">
+                  <a:lumMod val="75000"/>
+                </a:schemeClr>
+              </a:solidFill>
+            </a:endParaRPr>
+          </a:p>
+        </p:txBody>
+      </p:sp>
+    </p:spTree>
+    <p:extLst>
+      <p:ext uri="{BB962C8B-B14F-4D97-AF65-F5344CB8AC3E}">
+        <p14:creationId xmlns:p14="http://schemas.microsoft.com/office/powerpoint/2010/main" val="4226222994"/>
+      </p:ext>
+    </p:extLst>
+  </p:cSld>
+  <p:clrMapOvr>
+    <a:masterClrMapping/>
+  </p:clrMapOvr>
+  <mc:AlternateContent xmlns:mc="http://schemas.openxmlformats.org/markup-compatibility/2006">
+    <mc:Choice xmlns:p14="http://schemas.microsoft.com/office/powerpoint/2010/main" Requires="p14">
+      <p:transition spd="med" p14:dur="700">
+        <p:fade/>
+      </p:transition>
+    </mc:Choice>
+    <mc:Fallback>
+      <p:transition spd="med">
+        <p:fade/>
+      </p:transition>
+    </mc:Fallback>
+  </mc:AlternateContent>
   <p:timing>
     <p:tnLst>
       <p:par>
@@ -4153,869 +5720,6 @@
       </p:par>
     </p:tnLst>
   </p:timing>
-</p:sld>
-</file>
-
-<file path=ppt/slides/slide6.xml><?xml version="1.0" encoding="utf-8"?>
-<p:sld xmlns:a="http://schemas.openxmlformats.org/drawingml/2006/main" xmlns:r="http://schemas.openxmlformats.org/officeDocument/2006/relationships" xmlns:p="http://schemas.openxmlformats.org/presentationml/2006/main">
-  <p:cSld>
-    <p:spTree>
-      <p:nvGrpSpPr>
-        <p:cNvPr id="1" name="">
-          <a:extLst>
-            <a:ext uri="{FF2B5EF4-FFF2-40B4-BE49-F238E27FC236}">
-              <a16:creationId xmlns:a16="http://schemas.microsoft.com/office/drawing/2014/main" id="{ACAFECE9-6D9E-9E37-8E1A-D2A31B44E809}"/>
-            </a:ext>
-          </a:extLst>
-        </p:cNvPr>
-        <p:cNvGrpSpPr/>
-        <p:nvPr/>
-      </p:nvGrpSpPr>
-      <p:grpSpPr>
-        <a:xfrm>
-          <a:off x="0" y="0"/>
-          <a:ext cx="0" cy="0"/>
-          <a:chOff x="0" y="0"/>
-          <a:chExt cx="0" cy="0"/>
-        </a:xfrm>
-      </p:grpSpPr>
-      <p:sp>
-        <p:nvSpPr>
-          <p:cNvPr id="5" name="TextBox 4">
-            <a:extLst>
-              <a:ext uri="{FF2B5EF4-FFF2-40B4-BE49-F238E27FC236}">
-                <a16:creationId xmlns:a16="http://schemas.microsoft.com/office/drawing/2014/main" id="{D4E43D52-11D0-9A6F-651B-664FF4584B65}"/>
-              </a:ext>
-            </a:extLst>
-          </p:cNvPr>
-          <p:cNvSpPr txBox="1"/>
-          <p:nvPr/>
-        </p:nvSpPr>
-        <p:spPr>
-          <a:xfrm>
-            <a:off x="1956390" y="6488668"/>
-            <a:ext cx="7658250" cy="369332"/>
-          </a:xfrm>
-          <a:prstGeom prst="rect">
-            <a:avLst/>
-          </a:prstGeom>
-          <a:noFill/>
-        </p:spPr>
-        <p:txBody>
-          <a:bodyPr wrap="none" rtlCol="0">
-            <a:spAutoFit/>
-          </a:bodyPr>
-          <a:lstStyle/>
-          <a:p>
-            <a:r>
-              <a:rPr lang="en-GB" dirty="0">
-                <a:solidFill>
-                  <a:schemeClr val="bg1">
-                    <a:lumMod val="75000"/>
-                  </a:schemeClr>
-                </a:solidFill>
-              </a:rPr>
-              <a:t>Dataset </a:t>
-            </a:r>
-            <a:r>
-              <a:rPr lang="en-GB" dirty="0" err="1">
-                <a:solidFill>
-                  <a:schemeClr val="bg1">
-                    <a:lumMod val="75000"/>
-                  </a:schemeClr>
-                </a:solidFill>
-              </a:rPr>
-              <a:t>Characterisitcs</a:t>
-            </a:r>
-            <a:r>
-              <a:rPr lang="en-GB" dirty="0">
-                <a:solidFill>
-                  <a:schemeClr val="bg1">
-                    <a:lumMod val="75000"/>
-                  </a:schemeClr>
-                </a:solidFill>
-              </a:rPr>
-              <a:t> </a:t>
-            </a:r>
-            <a:r>
-              <a:rPr lang="en-GB" dirty="0">
-                <a:solidFill>
-                  <a:schemeClr val="bg1">
-                    <a:lumMod val="75000"/>
-                  </a:schemeClr>
-                </a:solidFill>
-                <a:latin typeface="Calibri" panose="020F0502020204030204" pitchFamily="34" charset="0"/>
-                <a:ea typeface="Calibri" panose="020F0502020204030204" pitchFamily="34" charset="0"/>
-                <a:cs typeface="Calibri" panose="020F0502020204030204" pitchFamily="34" charset="0"/>
-              </a:rPr>
-              <a:t>– </a:t>
-            </a:r>
-            <a:r>
-              <a:rPr lang="en-GB" dirty="0">
-                <a:latin typeface="Calibri" panose="020F0502020204030204" pitchFamily="34" charset="0"/>
-                <a:ea typeface="Calibri" panose="020F0502020204030204" pitchFamily="34" charset="0"/>
-                <a:cs typeface="Calibri" panose="020F0502020204030204" pitchFamily="34" charset="0"/>
-              </a:rPr>
-              <a:t>Baseline Model  </a:t>
-            </a:r>
-            <a:r>
-              <a:rPr lang="en-GB" dirty="0">
-                <a:solidFill>
-                  <a:schemeClr val="bg1">
-                    <a:lumMod val="75000"/>
-                  </a:schemeClr>
-                </a:solidFill>
-                <a:latin typeface="Calibri" panose="020F0502020204030204" pitchFamily="34" charset="0"/>
-                <a:ea typeface="Calibri" panose="020F0502020204030204" pitchFamily="34" charset="0"/>
-                <a:cs typeface="Calibri" panose="020F0502020204030204" pitchFamily="34" charset="0"/>
-              </a:rPr>
-              <a:t>- Neural Net – Results - Challenges</a:t>
-            </a:r>
-            <a:endParaRPr lang="de-DE" dirty="0">
-              <a:solidFill>
-                <a:schemeClr val="bg1">
-                  <a:lumMod val="75000"/>
-                </a:schemeClr>
-              </a:solidFill>
-            </a:endParaRPr>
-          </a:p>
-        </p:txBody>
-      </p:sp>
-      <p:pic>
-        <p:nvPicPr>
-          <p:cNvPr id="8" name="Picture 7" descr="A screenshot of a computer&#10;&#10;AI-generated content may be incorrect.">
-            <a:extLst>
-              <a:ext uri="{FF2B5EF4-FFF2-40B4-BE49-F238E27FC236}">
-                <a16:creationId xmlns:a16="http://schemas.microsoft.com/office/drawing/2014/main" id="{826FC09F-B539-64E9-5BFB-2E19E12C3B3E}"/>
-              </a:ext>
-            </a:extLst>
-          </p:cNvPr>
-          <p:cNvPicPr>
-            <a:picLocks noChangeAspect="1"/>
-          </p:cNvPicPr>
-          <p:nvPr/>
-        </p:nvPicPr>
-        <p:blipFill>
-          <a:blip r:embed="rId2">
-            <a:extLst>
-              <a:ext uri="{28A0092B-C50C-407E-A947-70E740481C1C}">
-                <a14:useLocalDpi xmlns:a14="http://schemas.microsoft.com/office/drawing/2010/main" val="0"/>
-              </a:ext>
-            </a:extLst>
-          </a:blip>
-          <a:stretch>
-            <a:fillRect/>
-          </a:stretch>
-        </p:blipFill>
-        <p:spPr>
-          <a:xfrm>
-            <a:off x="1613129" y="2057399"/>
-            <a:ext cx="8813341" cy="2748605"/>
-          </a:xfrm>
-          <a:prstGeom prst="rect">
-            <a:avLst/>
-          </a:prstGeom>
-          <a:ln w="19050">
-            <a:solidFill>
-              <a:schemeClr val="tx1"/>
-            </a:solidFill>
-          </a:ln>
-        </p:spPr>
-      </p:pic>
-      <p:pic>
-        <p:nvPicPr>
-          <p:cNvPr id="10" name="Picture 9" descr="A screenshot of a document&#10;&#10;AI-generated content may be incorrect.">
-            <a:extLst>
-              <a:ext uri="{FF2B5EF4-FFF2-40B4-BE49-F238E27FC236}">
-                <a16:creationId xmlns:a16="http://schemas.microsoft.com/office/drawing/2014/main" id="{A8BF8A03-866A-5220-CC7A-B17CC0387014}"/>
-              </a:ext>
-            </a:extLst>
-          </p:cNvPr>
-          <p:cNvPicPr>
-            <a:picLocks noChangeAspect="1"/>
-          </p:cNvPicPr>
-          <p:nvPr/>
-        </p:nvPicPr>
-        <p:blipFill>
-          <a:blip r:embed="rId3">
-            <a:extLst>
-              <a:ext uri="{28A0092B-C50C-407E-A947-70E740481C1C}">
-                <a14:useLocalDpi xmlns:a14="http://schemas.microsoft.com/office/drawing/2010/main" val="0"/>
-              </a:ext>
-            </a:extLst>
-          </a:blip>
-          <a:stretch>
-            <a:fillRect/>
-          </a:stretch>
-        </p:blipFill>
-        <p:spPr>
-          <a:xfrm>
-            <a:off x="986659" y="0"/>
-            <a:ext cx="9671823" cy="6481981"/>
-          </a:xfrm>
-          <a:prstGeom prst="rect">
-            <a:avLst/>
-          </a:prstGeom>
-        </p:spPr>
-      </p:pic>
-    </p:spTree>
-    <p:extLst>
-      <p:ext uri="{BB962C8B-B14F-4D97-AF65-F5344CB8AC3E}">
-        <p14:creationId xmlns:p14="http://schemas.microsoft.com/office/powerpoint/2010/main" val="4226222994"/>
-      </p:ext>
-    </p:extLst>
-  </p:cSld>
-  <p:clrMapOvr>
-    <a:masterClrMapping/>
-  </p:clrMapOvr>
-  <p:timing>
-    <p:tnLst>
-      <p:par>
-        <p:cTn id="1" dur="indefinite" restart="never" nodeType="tmRoot">
-          <p:childTnLst>
-            <p:seq concurrent="1" nextAc="seek">
-              <p:cTn id="2" dur="indefinite" nodeType="mainSeq">
-                <p:childTnLst>
-                  <p:par>
-                    <p:cTn id="3" fill="hold">
-                      <p:stCondLst>
-                        <p:cond delay="indefinite"/>
-                      </p:stCondLst>
-                      <p:childTnLst>
-                        <p:par>
-                          <p:cTn id="4" fill="hold">
-                            <p:stCondLst>
-                              <p:cond delay="0"/>
-                            </p:stCondLst>
-                            <p:childTnLst>
-                              <p:par>
-                                <p:cTn id="5" presetID="10" presetClass="entr" presetSubtype="0" fill="hold" nodeType="clickEffect">
-                                  <p:stCondLst>
-                                    <p:cond delay="0"/>
-                                  </p:stCondLst>
-                                  <p:childTnLst>
-                                    <p:set>
-                                      <p:cBhvr>
-                                        <p:cTn id="6" dur="1" fill="hold">
-                                          <p:stCondLst>
-                                            <p:cond delay="0"/>
-                                          </p:stCondLst>
-                                        </p:cTn>
-                                        <p:tgtEl>
-                                          <p:spTgt spid="8"/>
-                                        </p:tgtEl>
-                                        <p:attrNameLst>
-                                          <p:attrName>style.visibility</p:attrName>
-                                        </p:attrNameLst>
-                                      </p:cBhvr>
-                                      <p:to>
-                                        <p:strVal val="visible"/>
-                                      </p:to>
-                                    </p:set>
-                                    <p:animEffect transition="in" filter="fade">
-                                      <p:cBhvr>
-                                        <p:cTn id="7" dur="500"/>
-                                        <p:tgtEl>
-                                          <p:spTgt spid="8"/>
-                                        </p:tgtEl>
-                                      </p:cBhvr>
-                                    </p:animEffect>
-                                  </p:childTnLst>
-                                </p:cTn>
-                              </p:par>
-                              <p:par>
-                                <p:cTn id="8" presetID="10" presetClass="exit" presetSubtype="0" fill="hold" nodeType="withEffect">
-                                  <p:stCondLst>
-                                    <p:cond delay="0"/>
-                                  </p:stCondLst>
-                                  <p:childTnLst>
-                                    <p:animEffect transition="out" filter="fade">
-                                      <p:cBhvr>
-                                        <p:cTn id="9" dur="500"/>
-                                        <p:tgtEl>
-                                          <p:spTgt spid="10"/>
-                                        </p:tgtEl>
-                                      </p:cBhvr>
-                                    </p:animEffect>
-                                    <p:set>
-                                      <p:cBhvr>
-                                        <p:cTn id="10" dur="1" fill="hold">
-                                          <p:stCondLst>
-                                            <p:cond delay="499"/>
-                                          </p:stCondLst>
-                                        </p:cTn>
-                                        <p:tgtEl>
-                                          <p:spTgt spid="10"/>
-                                        </p:tgtEl>
-                                        <p:attrNameLst>
-                                          <p:attrName>style.visibility</p:attrName>
-                                        </p:attrNameLst>
-                                      </p:cBhvr>
-                                      <p:to>
-                                        <p:strVal val="hidden"/>
-                                      </p:to>
-                                    </p:set>
-                                  </p:childTnLst>
-                                </p:cTn>
-                              </p:par>
-                            </p:childTnLst>
-                          </p:cTn>
-                        </p:par>
-                      </p:childTnLst>
-                    </p:cTn>
-                  </p:par>
-                </p:childTnLst>
-              </p:cTn>
-              <p:prevCondLst>
-                <p:cond evt="onPrev" delay="0">
-                  <p:tgtEl>
-                    <p:sldTgt/>
-                  </p:tgtEl>
-                </p:cond>
-              </p:prevCondLst>
-              <p:nextCondLst>
-                <p:cond evt="onNext" delay="0">
-                  <p:tgtEl>
-                    <p:sldTgt/>
-                  </p:tgtEl>
-                </p:cond>
-              </p:nextCondLst>
-            </p:seq>
-          </p:childTnLst>
-        </p:cTn>
-      </p:par>
-    </p:tnLst>
-  </p:timing>
-</p:sld>
-</file>
-
-<file path=ppt/slides/slide7.xml><?xml version="1.0" encoding="utf-8"?>
-<p:sld xmlns:a="http://schemas.openxmlformats.org/drawingml/2006/main" xmlns:r="http://schemas.openxmlformats.org/officeDocument/2006/relationships" xmlns:p="http://schemas.openxmlformats.org/presentationml/2006/main">
-  <p:cSld>
-    <p:spTree>
-      <p:nvGrpSpPr>
-        <p:cNvPr id="1" name="">
-          <a:extLst>
-            <a:ext uri="{FF2B5EF4-FFF2-40B4-BE49-F238E27FC236}">
-              <a16:creationId xmlns:a16="http://schemas.microsoft.com/office/drawing/2014/main" id="{9DF07184-045D-5BD1-0E31-4047B75F7005}"/>
-            </a:ext>
-          </a:extLst>
-        </p:cNvPr>
-        <p:cNvGrpSpPr/>
-        <p:nvPr/>
-      </p:nvGrpSpPr>
-      <p:grpSpPr>
-        <a:xfrm>
-          <a:off x="0" y="0"/>
-          <a:ext cx="0" cy="0"/>
-          <a:chOff x="0" y="0"/>
-          <a:chExt cx="0" cy="0"/>
-        </a:xfrm>
-      </p:grpSpPr>
-      <p:sp>
-        <p:nvSpPr>
-          <p:cNvPr id="5" name="TextBox 4">
-            <a:extLst>
-              <a:ext uri="{FF2B5EF4-FFF2-40B4-BE49-F238E27FC236}">
-                <a16:creationId xmlns:a16="http://schemas.microsoft.com/office/drawing/2014/main" id="{4CD4AAC1-5BC9-575A-01DD-BE2C9A44A27A}"/>
-              </a:ext>
-            </a:extLst>
-          </p:cNvPr>
-          <p:cNvSpPr txBox="1"/>
-          <p:nvPr/>
-        </p:nvSpPr>
-        <p:spPr>
-          <a:xfrm>
-            <a:off x="1956390" y="6488668"/>
-            <a:ext cx="7658250" cy="369332"/>
-          </a:xfrm>
-          <a:prstGeom prst="rect">
-            <a:avLst/>
-          </a:prstGeom>
-          <a:noFill/>
-        </p:spPr>
-        <p:txBody>
-          <a:bodyPr wrap="none" rtlCol="0">
-            <a:spAutoFit/>
-          </a:bodyPr>
-          <a:lstStyle/>
-          <a:p>
-            <a:r>
-              <a:rPr lang="en-GB" dirty="0">
-                <a:solidFill>
-                  <a:schemeClr val="bg1">
-                    <a:lumMod val="75000"/>
-                  </a:schemeClr>
-                </a:solidFill>
-              </a:rPr>
-              <a:t>Dataset </a:t>
-            </a:r>
-            <a:r>
-              <a:rPr lang="en-GB" dirty="0" err="1">
-                <a:solidFill>
-                  <a:schemeClr val="bg1">
-                    <a:lumMod val="75000"/>
-                  </a:schemeClr>
-                </a:solidFill>
-              </a:rPr>
-              <a:t>Characterisitcs</a:t>
-            </a:r>
-            <a:r>
-              <a:rPr lang="en-GB" dirty="0">
-                <a:solidFill>
-                  <a:schemeClr val="bg1">
-                    <a:lumMod val="75000"/>
-                  </a:schemeClr>
-                </a:solidFill>
-              </a:rPr>
-              <a:t> </a:t>
-            </a:r>
-            <a:r>
-              <a:rPr lang="en-GB" dirty="0">
-                <a:solidFill>
-                  <a:schemeClr val="bg1">
-                    <a:lumMod val="75000"/>
-                  </a:schemeClr>
-                </a:solidFill>
-                <a:latin typeface="Calibri" panose="020F0502020204030204" pitchFamily="34" charset="0"/>
-                <a:ea typeface="Calibri" panose="020F0502020204030204" pitchFamily="34" charset="0"/>
-                <a:cs typeface="Calibri" panose="020F0502020204030204" pitchFamily="34" charset="0"/>
-              </a:rPr>
-              <a:t>– </a:t>
-            </a:r>
-            <a:r>
-              <a:rPr lang="en-GB" dirty="0">
-                <a:latin typeface="Calibri" panose="020F0502020204030204" pitchFamily="34" charset="0"/>
-                <a:ea typeface="Calibri" panose="020F0502020204030204" pitchFamily="34" charset="0"/>
-                <a:cs typeface="Calibri" panose="020F0502020204030204" pitchFamily="34" charset="0"/>
-              </a:rPr>
-              <a:t>Baseline Model  </a:t>
-            </a:r>
-            <a:r>
-              <a:rPr lang="en-GB" dirty="0">
-                <a:solidFill>
-                  <a:schemeClr val="bg1">
-                    <a:lumMod val="75000"/>
-                  </a:schemeClr>
-                </a:solidFill>
-                <a:latin typeface="Calibri" panose="020F0502020204030204" pitchFamily="34" charset="0"/>
-                <a:ea typeface="Calibri" panose="020F0502020204030204" pitchFamily="34" charset="0"/>
-                <a:cs typeface="Calibri" panose="020F0502020204030204" pitchFamily="34" charset="0"/>
-              </a:rPr>
-              <a:t>- Neural Net – Results - Challenges</a:t>
-            </a:r>
-            <a:endParaRPr lang="de-DE" dirty="0">
-              <a:solidFill>
-                <a:schemeClr val="bg1">
-                  <a:lumMod val="75000"/>
-                </a:schemeClr>
-              </a:solidFill>
-            </a:endParaRPr>
-          </a:p>
-        </p:txBody>
-      </p:sp>
-      <p:sp>
-        <p:nvSpPr>
-          <p:cNvPr id="2" name="TextBox 1">
-            <a:extLst>
-              <a:ext uri="{FF2B5EF4-FFF2-40B4-BE49-F238E27FC236}">
-                <a16:creationId xmlns:a16="http://schemas.microsoft.com/office/drawing/2014/main" id="{6860FBA4-C762-28DA-D1C2-CB3A95298DD4}"/>
-              </a:ext>
-            </a:extLst>
-          </p:cNvPr>
-          <p:cNvSpPr txBox="1"/>
-          <p:nvPr/>
-        </p:nvSpPr>
-        <p:spPr>
-          <a:xfrm>
-            <a:off x="7192926" y="3115340"/>
-            <a:ext cx="2821991" cy="369332"/>
-          </a:xfrm>
-          <a:prstGeom prst="rect">
-            <a:avLst/>
-          </a:prstGeom>
-          <a:noFill/>
-        </p:spPr>
-        <p:txBody>
-          <a:bodyPr wrap="none" rtlCol="0">
-            <a:spAutoFit/>
-          </a:bodyPr>
-          <a:lstStyle/>
-          <a:p>
-            <a:r>
-              <a:rPr lang="en-GB" dirty="0"/>
-              <a:t>Screenshot of </a:t>
-            </a:r>
-            <a:r>
-              <a:rPr lang="en-GB" dirty="0" err="1"/>
-              <a:t>nn</a:t>
-            </a:r>
-            <a:r>
-              <a:rPr lang="en-GB" dirty="0"/>
-              <a:t> structure</a:t>
-            </a:r>
-            <a:endParaRPr lang="de-DE" dirty="0"/>
-          </a:p>
-        </p:txBody>
-      </p:sp>
-    </p:spTree>
-    <p:extLst>
-      <p:ext uri="{BB962C8B-B14F-4D97-AF65-F5344CB8AC3E}">
-        <p14:creationId xmlns:p14="http://schemas.microsoft.com/office/powerpoint/2010/main" val="1731321607"/>
-      </p:ext>
-    </p:extLst>
-  </p:cSld>
-  <p:clrMapOvr>
-    <a:masterClrMapping/>
-  </p:clrMapOvr>
-</p:sld>
-</file>
-
-<file path=ppt/slides/slide8.xml><?xml version="1.0" encoding="utf-8"?>
-<p:sld xmlns:a="http://schemas.openxmlformats.org/drawingml/2006/main" xmlns:r="http://schemas.openxmlformats.org/officeDocument/2006/relationships" xmlns:p="http://schemas.openxmlformats.org/presentationml/2006/main">
-  <p:cSld>
-    <p:spTree>
-      <p:nvGrpSpPr>
-        <p:cNvPr id="1" name="">
-          <a:extLst>
-            <a:ext uri="{FF2B5EF4-FFF2-40B4-BE49-F238E27FC236}">
-              <a16:creationId xmlns:a16="http://schemas.microsoft.com/office/drawing/2014/main" id="{080F9B6C-ADC8-1490-E36A-62E075121EA4}"/>
-            </a:ext>
-          </a:extLst>
-        </p:cNvPr>
-        <p:cNvGrpSpPr/>
-        <p:nvPr/>
-      </p:nvGrpSpPr>
-      <p:grpSpPr>
-        <a:xfrm>
-          <a:off x="0" y="0"/>
-          <a:ext cx="0" cy="0"/>
-          <a:chOff x="0" y="0"/>
-          <a:chExt cx="0" cy="0"/>
-        </a:xfrm>
-      </p:grpSpPr>
-      <p:sp>
-        <p:nvSpPr>
-          <p:cNvPr id="5" name="TextBox 4">
-            <a:extLst>
-              <a:ext uri="{FF2B5EF4-FFF2-40B4-BE49-F238E27FC236}">
-                <a16:creationId xmlns:a16="http://schemas.microsoft.com/office/drawing/2014/main" id="{E7525199-3413-D073-0B3A-F7F48810FB24}"/>
-              </a:ext>
-            </a:extLst>
-          </p:cNvPr>
-          <p:cNvSpPr txBox="1"/>
-          <p:nvPr/>
-        </p:nvSpPr>
-        <p:spPr>
-          <a:xfrm>
-            <a:off x="1956390" y="6488668"/>
-            <a:ext cx="7658250" cy="369332"/>
-          </a:xfrm>
-          <a:prstGeom prst="rect">
-            <a:avLst/>
-          </a:prstGeom>
-          <a:noFill/>
-        </p:spPr>
-        <p:txBody>
-          <a:bodyPr wrap="none" rtlCol="0">
-            <a:spAutoFit/>
-          </a:bodyPr>
-          <a:lstStyle/>
-          <a:p>
-            <a:r>
-              <a:rPr lang="en-GB" dirty="0">
-                <a:solidFill>
-                  <a:schemeClr val="bg1">
-                    <a:lumMod val="75000"/>
-                  </a:schemeClr>
-                </a:solidFill>
-              </a:rPr>
-              <a:t>Dataset </a:t>
-            </a:r>
-            <a:r>
-              <a:rPr lang="en-GB" dirty="0" err="1">
-                <a:solidFill>
-                  <a:schemeClr val="bg1">
-                    <a:lumMod val="75000"/>
-                  </a:schemeClr>
-                </a:solidFill>
-              </a:rPr>
-              <a:t>Characterisitcs</a:t>
-            </a:r>
-            <a:r>
-              <a:rPr lang="en-GB" dirty="0">
-                <a:solidFill>
-                  <a:schemeClr val="bg1">
-                    <a:lumMod val="75000"/>
-                  </a:schemeClr>
-                </a:solidFill>
-              </a:rPr>
-              <a:t> </a:t>
-            </a:r>
-            <a:r>
-              <a:rPr lang="en-GB" dirty="0">
-                <a:solidFill>
-                  <a:schemeClr val="bg1">
-                    <a:lumMod val="75000"/>
-                  </a:schemeClr>
-                </a:solidFill>
-                <a:latin typeface="Calibri" panose="020F0502020204030204" pitchFamily="34" charset="0"/>
-                <a:ea typeface="Calibri" panose="020F0502020204030204" pitchFamily="34" charset="0"/>
-                <a:cs typeface="Calibri" panose="020F0502020204030204" pitchFamily="34" charset="0"/>
-              </a:rPr>
-              <a:t>– </a:t>
-            </a:r>
-            <a:r>
-              <a:rPr lang="en-GB" dirty="0">
-                <a:latin typeface="Calibri" panose="020F0502020204030204" pitchFamily="34" charset="0"/>
-                <a:ea typeface="Calibri" panose="020F0502020204030204" pitchFamily="34" charset="0"/>
-                <a:cs typeface="Calibri" panose="020F0502020204030204" pitchFamily="34" charset="0"/>
-              </a:rPr>
-              <a:t>Baseline Model  </a:t>
-            </a:r>
-            <a:r>
-              <a:rPr lang="en-GB" dirty="0">
-                <a:solidFill>
-                  <a:schemeClr val="bg1">
-                    <a:lumMod val="75000"/>
-                  </a:schemeClr>
-                </a:solidFill>
-                <a:latin typeface="Calibri" panose="020F0502020204030204" pitchFamily="34" charset="0"/>
-                <a:ea typeface="Calibri" panose="020F0502020204030204" pitchFamily="34" charset="0"/>
-                <a:cs typeface="Calibri" panose="020F0502020204030204" pitchFamily="34" charset="0"/>
-              </a:rPr>
-              <a:t>- Neural Net – Results - Challenges</a:t>
-            </a:r>
-            <a:endParaRPr lang="de-DE" dirty="0">
-              <a:solidFill>
-                <a:schemeClr val="bg1">
-                  <a:lumMod val="75000"/>
-                </a:schemeClr>
-              </a:solidFill>
-            </a:endParaRPr>
-          </a:p>
-        </p:txBody>
-      </p:sp>
-      <p:sp>
-        <p:nvSpPr>
-          <p:cNvPr id="2" name="TextBox 1">
-            <a:extLst>
-              <a:ext uri="{FF2B5EF4-FFF2-40B4-BE49-F238E27FC236}">
-                <a16:creationId xmlns:a16="http://schemas.microsoft.com/office/drawing/2014/main" id="{59A41CDB-4822-BFA5-F338-27F1BD52A3BD}"/>
-              </a:ext>
-            </a:extLst>
-          </p:cNvPr>
-          <p:cNvSpPr txBox="1"/>
-          <p:nvPr/>
-        </p:nvSpPr>
-        <p:spPr>
-          <a:xfrm>
-            <a:off x="7192926" y="3115340"/>
-            <a:ext cx="1089337" cy="369332"/>
-          </a:xfrm>
-          <a:prstGeom prst="rect">
-            <a:avLst/>
-          </a:prstGeom>
-          <a:noFill/>
-        </p:spPr>
-        <p:txBody>
-          <a:bodyPr wrap="none" rtlCol="0">
-            <a:spAutoFit/>
-          </a:bodyPr>
-          <a:lstStyle/>
-          <a:p>
-            <a:r>
-              <a:rPr lang="en-GB" dirty="0"/>
-              <a:t>Loss plot</a:t>
-            </a:r>
-            <a:endParaRPr lang="de-DE" dirty="0"/>
-          </a:p>
-        </p:txBody>
-      </p:sp>
-    </p:spTree>
-    <p:extLst>
-      <p:ext uri="{BB962C8B-B14F-4D97-AF65-F5344CB8AC3E}">
-        <p14:creationId xmlns:p14="http://schemas.microsoft.com/office/powerpoint/2010/main" val="1448705476"/>
-      </p:ext>
-    </p:extLst>
-  </p:cSld>
-  <p:clrMapOvr>
-    <a:masterClrMapping/>
-  </p:clrMapOvr>
-</p:sld>
-</file>
-
-<file path=ppt/slides/slide9.xml><?xml version="1.0" encoding="utf-8"?>
-<p:sld xmlns:a="http://schemas.openxmlformats.org/drawingml/2006/main" xmlns:r="http://schemas.openxmlformats.org/officeDocument/2006/relationships" xmlns:p="http://schemas.openxmlformats.org/presentationml/2006/main">
-  <p:cSld>
-    <p:spTree>
-      <p:nvGrpSpPr>
-        <p:cNvPr id="1" name="">
-          <a:extLst>
-            <a:ext uri="{FF2B5EF4-FFF2-40B4-BE49-F238E27FC236}">
-              <a16:creationId xmlns:a16="http://schemas.microsoft.com/office/drawing/2014/main" id="{05D4050B-A8AD-D44C-BDB5-DAEF0748352F}"/>
-            </a:ext>
-          </a:extLst>
-        </p:cNvPr>
-        <p:cNvGrpSpPr/>
-        <p:nvPr/>
-      </p:nvGrpSpPr>
-      <p:grpSpPr>
-        <a:xfrm>
-          <a:off x="0" y="0"/>
-          <a:ext cx="0" cy="0"/>
-          <a:chOff x="0" y="0"/>
-          <a:chExt cx="0" cy="0"/>
-        </a:xfrm>
-      </p:grpSpPr>
-      <p:sp>
-        <p:nvSpPr>
-          <p:cNvPr id="5" name="TextBox 4">
-            <a:extLst>
-              <a:ext uri="{FF2B5EF4-FFF2-40B4-BE49-F238E27FC236}">
-                <a16:creationId xmlns:a16="http://schemas.microsoft.com/office/drawing/2014/main" id="{99A00947-4782-3164-3F43-60FB01F5A96C}"/>
-              </a:ext>
-            </a:extLst>
-          </p:cNvPr>
-          <p:cNvSpPr txBox="1"/>
-          <p:nvPr/>
-        </p:nvSpPr>
-        <p:spPr>
-          <a:xfrm>
-            <a:off x="1956390" y="6488668"/>
-            <a:ext cx="7658250" cy="369332"/>
-          </a:xfrm>
-          <a:prstGeom prst="rect">
-            <a:avLst/>
-          </a:prstGeom>
-          <a:noFill/>
-        </p:spPr>
-        <p:txBody>
-          <a:bodyPr wrap="none" rtlCol="0">
-            <a:spAutoFit/>
-          </a:bodyPr>
-          <a:lstStyle/>
-          <a:p>
-            <a:r>
-              <a:rPr lang="en-GB" dirty="0">
-                <a:solidFill>
-                  <a:schemeClr val="bg1">
-                    <a:lumMod val="75000"/>
-                  </a:schemeClr>
-                </a:solidFill>
-              </a:rPr>
-              <a:t>Dataset </a:t>
-            </a:r>
-            <a:r>
-              <a:rPr lang="en-GB" dirty="0" err="1">
-                <a:solidFill>
-                  <a:schemeClr val="bg1">
-                    <a:lumMod val="75000"/>
-                  </a:schemeClr>
-                </a:solidFill>
-              </a:rPr>
-              <a:t>Characterisitcs</a:t>
-            </a:r>
-            <a:r>
-              <a:rPr lang="en-GB" dirty="0">
-                <a:solidFill>
-                  <a:schemeClr val="bg1">
-                    <a:lumMod val="75000"/>
-                  </a:schemeClr>
-                </a:solidFill>
-              </a:rPr>
-              <a:t> </a:t>
-            </a:r>
-            <a:r>
-              <a:rPr lang="en-GB" dirty="0">
-                <a:solidFill>
-                  <a:schemeClr val="bg1">
-                    <a:lumMod val="75000"/>
-                  </a:schemeClr>
-                </a:solidFill>
-                <a:latin typeface="Calibri" panose="020F0502020204030204" pitchFamily="34" charset="0"/>
-                <a:ea typeface="Calibri" panose="020F0502020204030204" pitchFamily="34" charset="0"/>
-                <a:cs typeface="Calibri" panose="020F0502020204030204" pitchFamily="34" charset="0"/>
-              </a:rPr>
-              <a:t>– </a:t>
-            </a:r>
-            <a:r>
-              <a:rPr lang="en-GB" dirty="0">
-                <a:latin typeface="Calibri" panose="020F0502020204030204" pitchFamily="34" charset="0"/>
-                <a:ea typeface="Calibri" panose="020F0502020204030204" pitchFamily="34" charset="0"/>
-                <a:cs typeface="Calibri" panose="020F0502020204030204" pitchFamily="34" charset="0"/>
-              </a:rPr>
-              <a:t>Baseline Model  </a:t>
-            </a:r>
-            <a:r>
-              <a:rPr lang="en-GB" dirty="0">
-                <a:solidFill>
-                  <a:schemeClr val="bg1">
-                    <a:lumMod val="75000"/>
-                  </a:schemeClr>
-                </a:solidFill>
-                <a:latin typeface="Calibri" panose="020F0502020204030204" pitchFamily="34" charset="0"/>
-                <a:ea typeface="Calibri" panose="020F0502020204030204" pitchFamily="34" charset="0"/>
-                <a:cs typeface="Calibri" panose="020F0502020204030204" pitchFamily="34" charset="0"/>
-              </a:rPr>
-              <a:t>- Neural Net – Results - Challenges</a:t>
-            </a:r>
-            <a:endParaRPr lang="de-DE" dirty="0">
-              <a:solidFill>
-                <a:schemeClr val="bg1">
-                  <a:lumMod val="75000"/>
-                </a:schemeClr>
-              </a:solidFill>
-            </a:endParaRPr>
-          </a:p>
-        </p:txBody>
-      </p:sp>
-      <p:sp>
-        <p:nvSpPr>
-          <p:cNvPr id="2" name="TextBox 1">
-            <a:extLst>
-              <a:ext uri="{FF2B5EF4-FFF2-40B4-BE49-F238E27FC236}">
-                <a16:creationId xmlns:a16="http://schemas.microsoft.com/office/drawing/2014/main" id="{6A7C3F15-2196-DC03-ED48-2696369A2B11}"/>
-              </a:ext>
-            </a:extLst>
-          </p:cNvPr>
-          <p:cNvSpPr txBox="1"/>
-          <p:nvPr/>
-        </p:nvSpPr>
-        <p:spPr>
-          <a:xfrm>
-            <a:off x="7192926" y="3115340"/>
-            <a:ext cx="2177263" cy="369332"/>
-          </a:xfrm>
-          <a:prstGeom prst="rect">
-            <a:avLst/>
-          </a:prstGeom>
-          <a:noFill/>
-        </p:spPr>
-        <p:txBody>
-          <a:bodyPr wrap="none" rtlCol="0">
-            <a:spAutoFit/>
-          </a:bodyPr>
-          <a:lstStyle/>
-          <a:p>
-            <a:r>
-              <a:rPr lang="en-GB" dirty="0"/>
-              <a:t>Mape scores as plot</a:t>
-            </a:r>
-            <a:endParaRPr lang="de-DE" dirty="0"/>
-          </a:p>
-        </p:txBody>
-      </p:sp>
-    </p:spTree>
-    <p:extLst>
-      <p:ext uri="{BB962C8B-B14F-4D97-AF65-F5344CB8AC3E}">
-        <p14:creationId xmlns:p14="http://schemas.microsoft.com/office/powerpoint/2010/main" val="2630275565"/>
-      </p:ext>
-    </p:extLst>
-  </p:cSld>
-  <p:clrMapOvr>
-    <a:masterClrMapping/>
-  </p:clrMapOvr>
 </p:sld>
 </file>
 

</xml_diff>

<commit_message>
updated plots and pptx
</commit_message>
<xml_diff>
--- a/4_Presentation/Group 3.pptx
+++ b/4_Presentation/Group 3.pptx
@@ -3420,13 +3420,13 @@
   <p:clrMapOvr>
     <a:masterClrMapping/>
   </p:clrMapOvr>
-  <mc:AlternateContent xmlns:mc="http://schemas.openxmlformats.org/markup-compatibility/2006">
-    <mc:Choice xmlns:p14="http://schemas.microsoft.com/office/powerpoint/2010/main" Requires="p14">
+  <mc:AlternateContent xmlns:mc="http://schemas.openxmlformats.org/markup-compatibility/2006" xmlns:p14="http://schemas.microsoft.com/office/powerpoint/2010/main">
+    <mc:Choice Requires="p14">
       <p:transition spd="med" p14:dur="700">
         <p:fade/>
       </p:transition>
     </mc:Choice>
-    <mc:Fallback>
+    <mc:Fallback xmlns="">
       <p:transition spd="med">
         <p:fade/>
       </p:transition>
@@ -3441,9 +3441,7 @@
     <p:bg>
       <p:bgPr>
         <a:solidFill>
-          <a:schemeClr val="bg1">
-            <a:alpha val="0"/>
-          </a:schemeClr>
+          <a:schemeClr val="tx1"/>
         </a:solidFill>
         <a:effectLst/>
       </p:bgPr>
@@ -3495,8 +3493,8 @@
         </p:blipFill>
         <p:spPr>
           <a:xfrm>
-            <a:off x="493948" y="37154"/>
-            <a:ext cx="11210371" cy="6787529"/>
+            <a:off x="464484" y="0"/>
+            <a:ext cx="11263031" cy="6858000"/>
           </a:xfrm>
           <a:prstGeom prst="rect">
             <a:avLst/>
@@ -3602,13 +3600,13 @@
   <p:clrMapOvr>
     <a:masterClrMapping/>
   </p:clrMapOvr>
-  <mc:AlternateContent xmlns:mc="http://schemas.openxmlformats.org/markup-compatibility/2006">
-    <mc:Choice xmlns:p14="http://schemas.microsoft.com/office/powerpoint/2010/main" Requires="p14">
+  <mc:AlternateContent xmlns:mc="http://schemas.openxmlformats.org/markup-compatibility/2006" xmlns:p14="http://schemas.microsoft.com/office/powerpoint/2010/main">
+    <mc:Choice Requires="p14">
       <p:transition spd="med" p14:dur="700">
         <p:fade/>
       </p:transition>
     </mc:Choice>
-    <mc:Fallback>
+    <mc:Fallback xmlns="">
       <p:transition spd="med">
         <p:fade/>
       </p:transition>
@@ -3768,13 +3766,13 @@
   <p:clrMapOvr>
     <a:masterClrMapping/>
   </p:clrMapOvr>
-  <mc:AlternateContent xmlns:mc="http://schemas.openxmlformats.org/markup-compatibility/2006">
-    <mc:Choice xmlns:p14="http://schemas.microsoft.com/office/powerpoint/2010/main" Requires="p14">
+  <mc:AlternateContent xmlns:mc="http://schemas.openxmlformats.org/markup-compatibility/2006" xmlns:p14="http://schemas.microsoft.com/office/powerpoint/2010/main">
+    <mc:Choice Requires="p14">
       <p:transition spd="med" p14:dur="700">
         <p:fade/>
       </p:transition>
     </mc:Choice>
-    <mc:Fallback>
+    <mc:Fallback xmlns="">
       <p:transition spd="med">
         <p:fade/>
       </p:transition>
@@ -3935,13 +3933,13 @@
   <p:clrMapOvr>
     <a:masterClrMapping/>
   </p:clrMapOvr>
-  <mc:AlternateContent xmlns:mc="http://schemas.openxmlformats.org/markup-compatibility/2006">
-    <mc:Choice xmlns:p14="http://schemas.microsoft.com/office/powerpoint/2010/main" Requires="p14">
+  <mc:AlternateContent xmlns:mc="http://schemas.openxmlformats.org/markup-compatibility/2006" xmlns:p14="http://schemas.microsoft.com/office/powerpoint/2010/main">
+    <mc:Choice Requires="p14">
       <p:transition spd="med" p14:dur="700">
         <p:fade/>
       </p:transition>
     </mc:Choice>
-    <mc:Fallback>
+    <mc:Fallback xmlns="">
       <p:transition spd="med">
         <p:fade/>
       </p:transition>
@@ -4102,13 +4100,13 @@
   <p:clrMapOvr>
     <a:masterClrMapping/>
   </p:clrMapOvr>
-  <mc:AlternateContent xmlns:mc="http://schemas.openxmlformats.org/markup-compatibility/2006">
-    <mc:Choice xmlns:p14="http://schemas.microsoft.com/office/powerpoint/2010/main" Requires="p14">
+  <mc:AlternateContent xmlns:mc="http://schemas.openxmlformats.org/markup-compatibility/2006" xmlns:p14="http://schemas.microsoft.com/office/powerpoint/2010/main">
+    <mc:Choice Requires="p14">
       <p:transition spd="med" p14:dur="700">
         <p:fade/>
       </p:transition>
     </mc:Choice>
-    <mc:Fallback>
+    <mc:Fallback xmlns="">
       <p:transition spd="med">
         <p:fade/>
       </p:transition>
@@ -4284,13 +4282,13 @@
   <p:clrMapOvr>
     <a:masterClrMapping/>
   </p:clrMapOvr>
-  <mc:AlternateContent xmlns:mc="http://schemas.openxmlformats.org/markup-compatibility/2006">
-    <mc:Choice xmlns:p14="http://schemas.microsoft.com/office/powerpoint/2010/main" Requires="p14">
+  <mc:AlternateContent xmlns:mc="http://schemas.openxmlformats.org/markup-compatibility/2006" xmlns:p14="http://schemas.microsoft.com/office/powerpoint/2010/main">
+    <mc:Choice Requires="p14">
       <p:transition spd="med" p14:dur="700">
         <p:fade/>
       </p:transition>
     </mc:Choice>
-    <mc:Fallback>
+    <mc:Fallback xmlns="">
       <p:transition spd="med">
         <p:fade/>
       </p:transition>
@@ -4462,13 +4460,13 @@
   <p:clrMapOvr>
     <a:masterClrMapping/>
   </p:clrMapOvr>
-  <mc:AlternateContent xmlns:mc="http://schemas.openxmlformats.org/markup-compatibility/2006">
-    <mc:Choice xmlns:p14="http://schemas.microsoft.com/office/powerpoint/2010/main" Requires="p14">
+  <mc:AlternateContent xmlns:mc="http://schemas.openxmlformats.org/markup-compatibility/2006" xmlns:p14="http://schemas.microsoft.com/office/powerpoint/2010/main">
+    <mc:Choice Requires="p14">
       <p:transition spd="med" p14:dur="700">
         <p:fade/>
       </p:transition>
     </mc:Choice>
-    <mc:Fallback>
+    <mc:Fallback xmlns="">
       <p:transition spd="med">
         <p:fade/>
       </p:transition>
@@ -4646,13 +4644,13 @@
   <p:clrMapOvr>
     <a:masterClrMapping/>
   </p:clrMapOvr>
-  <mc:AlternateContent xmlns:mc="http://schemas.openxmlformats.org/markup-compatibility/2006">
-    <mc:Choice xmlns:p14="http://schemas.microsoft.com/office/powerpoint/2010/main" Requires="p14">
+  <mc:AlternateContent xmlns:mc="http://schemas.openxmlformats.org/markup-compatibility/2006" xmlns:p14="http://schemas.microsoft.com/office/powerpoint/2010/main">
+    <mc:Choice Requires="p14">
       <p:transition spd="med" p14:dur="700">
         <p:fade/>
       </p:transition>
     </mc:Choice>
-    <mc:Fallback>
+    <mc:Fallback xmlns="">
       <p:transition spd="med">
         <p:fade/>
       </p:transition>
@@ -4830,13 +4828,13 @@
   <p:clrMapOvr>
     <a:masterClrMapping/>
   </p:clrMapOvr>
-  <mc:AlternateContent xmlns:mc="http://schemas.openxmlformats.org/markup-compatibility/2006">
-    <mc:Choice xmlns:p14="http://schemas.microsoft.com/office/powerpoint/2010/main" Requires="p14">
+  <mc:AlternateContent xmlns:mc="http://schemas.openxmlformats.org/markup-compatibility/2006" xmlns:p14="http://schemas.microsoft.com/office/powerpoint/2010/main">
+    <mc:Choice Requires="p14">
       <p:transition spd="med" p14:dur="700">
         <p:fade/>
       </p:transition>
     </mc:Choice>
-    <mc:Fallback>
+    <mc:Fallback xmlns="">
       <p:transition spd="med">
         <p:fade/>
       </p:transition>
@@ -4969,13 +4967,13 @@
   <p:clrMapOvr>
     <a:masterClrMapping/>
   </p:clrMapOvr>
-  <mc:AlternateContent xmlns:mc="http://schemas.openxmlformats.org/markup-compatibility/2006">
-    <mc:Choice xmlns:p14="http://schemas.microsoft.com/office/powerpoint/2010/main" Requires="p14">
+  <mc:AlternateContent xmlns:mc="http://schemas.openxmlformats.org/markup-compatibility/2006" xmlns:p14="http://schemas.microsoft.com/office/powerpoint/2010/main">
+    <mc:Choice Requires="p14">
       <p:transition spd="med" p14:dur="700">
         <p:fade/>
       </p:transition>
     </mc:Choice>
-    <mc:Fallback>
+    <mc:Fallback xmlns="">
       <p:transition spd="med">
         <p:fade/>
       </p:transition>
@@ -5107,13 +5105,13 @@
   <p:clrMapOvr>
     <a:masterClrMapping/>
   </p:clrMapOvr>
-  <mc:AlternateContent xmlns:mc="http://schemas.openxmlformats.org/markup-compatibility/2006">
-    <mc:Choice xmlns:p14="http://schemas.microsoft.com/office/powerpoint/2010/main" Requires="p14">
+  <mc:AlternateContent xmlns:mc="http://schemas.openxmlformats.org/markup-compatibility/2006" xmlns:p14="http://schemas.microsoft.com/office/powerpoint/2010/main">
+    <mc:Choice Requires="p14">
       <p:transition spd="med" p14:dur="700">
         <p:fade/>
       </p:transition>
     </mc:Choice>
-    <mc:Fallback>
+    <mc:Fallback xmlns="">
       <p:transition spd="med">
         <p:fade/>
       </p:transition>
@@ -5245,13 +5243,13 @@
   <p:clrMapOvr>
     <a:masterClrMapping/>
   </p:clrMapOvr>
-  <mc:AlternateContent xmlns:mc="http://schemas.openxmlformats.org/markup-compatibility/2006">
-    <mc:Choice xmlns:p14="http://schemas.microsoft.com/office/powerpoint/2010/main" Requires="p14">
+  <mc:AlternateContent xmlns:mc="http://schemas.openxmlformats.org/markup-compatibility/2006" xmlns:p14="http://schemas.microsoft.com/office/powerpoint/2010/main">
+    <mc:Choice Requires="p14">
       <p:transition spd="med" p14:dur="700">
         <p:fade/>
       </p:transition>
     </mc:Choice>
-    <mc:Fallback>
+    <mc:Fallback xmlns="">
       <p:transition spd="med">
         <p:fade/>
       </p:transition>
@@ -5383,13 +5381,13 @@
   <p:clrMapOvr>
     <a:masterClrMapping/>
   </p:clrMapOvr>
-  <mc:AlternateContent xmlns:mc="http://schemas.openxmlformats.org/markup-compatibility/2006">
-    <mc:Choice xmlns:p14="http://schemas.microsoft.com/office/powerpoint/2010/main" Requires="p14">
+  <mc:AlternateContent xmlns:mc="http://schemas.openxmlformats.org/markup-compatibility/2006" xmlns:p14="http://schemas.microsoft.com/office/powerpoint/2010/main">
+    <mc:Choice Requires="p14">
       <p:transition spd="med" p14:dur="700">
         <p:fade/>
       </p:transition>
     </mc:Choice>
-    <mc:Fallback>
+    <mc:Fallback xmlns="">
       <p:transition spd="med">
         <p:fade/>
       </p:transition>
@@ -5590,13 +5588,13 @@
   <p:clrMapOvr>
     <a:masterClrMapping/>
   </p:clrMapOvr>
-  <mc:AlternateContent xmlns:mc="http://schemas.openxmlformats.org/markup-compatibility/2006">
-    <mc:Choice xmlns:p14="http://schemas.microsoft.com/office/powerpoint/2010/main" Requires="p14">
+  <mc:AlternateContent xmlns:mc="http://schemas.openxmlformats.org/markup-compatibility/2006" xmlns:p14="http://schemas.microsoft.com/office/powerpoint/2010/main">
+    <mc:Choice Requires="p14">
       <p:transition spd="med" p14:dur="700">
         <p:fade/>
       </p:transition>
     </mc:Choice>
-    <mc:Fallback>
+    <mc:Fallback xmlns="">
       <p:transition spd="med">
         <p:fade/>
       </p:transition>

</xml_diff>

<commit_message>
minor changes in presentation, will work on it later today
</commit_message>
<xml_diff>
--- a/4_Presentation/Group 3.pptx
+++ b/4_Presentation/Group 3.pptx
@@ -5,7 +5,7 @@
     <p:sldMasterId id="2147483648" r:id="rId1"/>
   </p:sldMasterIdLst>
   <p:notesMasterIdLst>
-    <p:notesMasterId r:id="rId17"/>
+    <p:notesMasterId r:id="rId19"/>
   </p:notesMasterIdLst>
   <p:sldIdLst>
     <p:sldId id="256" r:id="rId2"/>
@@ -23,6 +23,8 @@
     <p:sldId id="264" r:id="rId14"/>
     <p:sldId id="265" r:id="rId15"/>
     <p:sldId id="262" r:id="rId16"/>
+    <p:sldId id="276" r:id="rId17"/>
+    <p:sldId id="275" r:id="rId18"/>
   </p:sldIdLst>
   <p:sldSz cx="12192000" cy="6858000"/>
   <p:notesSz cx="6858000" cy="9144000"/>
@@ -650,7 +652,7 @@
           <a:p>
             <a:fld id="{D702BB35-AE6A-4528-8F32-D1F8A7B871D9}" type="datetimeFigureOut">
               <a:rPr lang="en-GB" smtClean="0"/>
-              <a:t>30/06/2025</a:t>
+              <a:t>01/07/2025</a:t>
             </a:fld>
             <a:endParaRPr lang="en-GB"/>
           </a:p>
@@ -2078,6 +2080,182 @@
 </p:notes>
 </file>
 
+<file path=ppt/notesSlides/notesSlide8.xml><?xml version="1.0" encoding="utf-8"?>
+<p:notes xmlns:a="http://schemas.openxmlformats.org/drawingml/2006/main" xmlns:r="http://schemas.openxmlformats.org/officeDocument/2006/relationships" xmlns:p="http://schemas.openxmlformats.org/presentationml/2006/main">
+  <p:cSld>
+    <p:spTree>
+      <p:nvGrpSpPr>
+        <p:cNvPr id="1" name=""/>
+        <p:cNvGrpSpPr/>
+        <p:nvPr/>
+      </p:nvGrpSpPr>
+      <p:grpSpPr>
+        <a:xfrm>
+          <a:off x="0" y="0"/>
+          <a:ext cx="0" cy="0"/>
+          <a:chOff x="0" y="0"/>
+          <a:chExt cx="0" cy="0"/>
+        </a:xfrm>
+      </p:grpSpPr>
+      <p:sp>
+        <p:nvSpPr>
+          <p:cNvPr id="2" name="Slide Image Placeholder 1"/>
+          <p:cNvSpPr>
+            <a:spLocks noGrp="1" noRot="1" noChangeAspect="1"/>
+          </p:cNvSpPr>
+          <p:nvPr>
+            <p:ph type="sldImg"/>
+          </p:nvPr>
+        </p:nvSpPr>
+        <p:spPr/>
+      </p:sp>
+      <p:sp>
+        <p:nvSpPr>
+          <p:cNvPr id="3" name="Notes Placeholder 2"/>
+          <p:cNvSpPr>
+            <a:spLocks noGrp="1"/>
+          </p:cNvSpPr>
+          <p:nvPr>
+            <p:ph type="body" idx="1"/>
+          </p:nvPr>
+        </p:nvSpPr>
+        <p:spPr/>
+        <p:txBody>
+          <a:bodyPr/>
+          <a:lstStyle/>
+          <a:p>
+            <a:r>
+              <a:rPr lang="en-US"/>
+              <a:t>Under construction</a:t>
+            </a:r>
+            <a:endParaRPr lang="en-GB" dirty="0"/>
+          </a:p>
+        </p:txBody>
+      </p:sp>
+      <p:sp>
+        <p:nvSpPr>
+          <p:cNvPr id="4" name="Slide Number Placeholder 3"/>
+          <p:cNvSpPr>
+            <a:spLocks noGrp="1"/>
+          </p:cNvSpPr>
+          <p:nvPr>
+            <p:ph type="sldNum" sz="quarter" idx="5"/>
+          </p:nvPr>
+        </p:nvSpPr>
+        <p:spPr/>
+        <p:txBody>
+          <a:bodyPr/>
+          <a:lstStyle/>
+          <a:p>
+            <a:fld id="{809340A9-5F99-47E5-A3AD-FD228EA849F8}" type="slidenum">
+              <a:rPr lang="en-GB" smtClean="0"/>
+              <a:t>16</a:t>
+            </a:fld>
+            <a:endParaRPr lang="en-GB"/>
+          </a:p>
+        </p:txBody>
+      </p:sp>
+    </p:spTree>
+    <p:extLst>
+      <p:ext uri="{BB962C8B-B14F-4D97-AF65-F5344CB8AC3E}">
+        <p14:creationId xmlns:p14="http://schemas.microsoft.com/office/powerpoint/2010/main" val="3287434431"/>
+      </p:ext>
+    </p:extLst>
+  </p:cSld>
+  <p:clrMapOvr>
+    <a:masterClrMapping/>
+  </p:clrMapOvr>
+</p:notes>
+</file>
+
+<file path=ppt/notesSlides/notesSlide9.xml><?xml version="1.0" encoding="utf-8"?>
+<p:notes xmlns:a="http://schemas.openxmlformats.org/drawingml/2006/main" xmlns:r="http://schemas.openxmlformats.org/officeDocument/2006/relationships" xmlns:p="http://schemas.openxmlformats.org/presentationml/2006/main">
+  <p:cSld>
+    <p:spTree>
+      <p:nvGrpSpPr>
+        <p:cNvPr id="1" name=""/>
+        <p:cNvGrpSpPr/>
+        <p:nvPr/>
+      </p:nvGrpSpPr>
+      <p:grpSpPr>
+        <a:xfrm>
+          <a:off x="0" y="0"/>
+          <a:ext cx="0" cy="0"/>
+          <a:chOff x="0" y="0"/>
+          <a:chExt cx="0" cy="0"/>
+        </a:xfrm>
+      </p:grpSpPr>
+      <p:sp>
+        <p:nvSpPr>
+          <p:cNvPr id="2" name="Slide Image Placeholder 1"/>
+          <p:cNvSpPr>
+            <a:spLocks noGrp="1" noRot="1" noChangeAspect="1"/>
+          </p:cNvSpPr>
+          <p:nvPr>
+            <p:ph type="sldImg"/>
+          </p:nvPr>
+        </p:nvSpPr>
+        <p:spPr/>
+      </p:sp>
+      <p:sp>
+        <p:nvSpPr>
+          <p:cNvPr id="3" name="Notes Placeholder 2"/>
+          <p:cNvSpPr>
+            <a:spLocks noGrp="1"/>
+          </p:cNvSpPr>
+          <p:nvPr>
+            <p:ph type="body" idx="1"/>
+          </p:nvPr>
+        </p:nvSpPr>
+        <p:spPr/>
+        <p:txBody>
+          <a:bodyPr/>
+          <a:lstStyle/>
+          <a:p>
+            <a:r>
+              <a:rPr lang="en-US" dirty="0"/>
+              <a:t>Will make it prettier but I think those are the points I want to talk about , you can also add yours and we can share this part so that we both talk about our experience</a:t>
+            </a:r>
+            <a:endParaRPr lang="en-GB" dirty="0"/>
+          </a:p>
+        </p:txBody>
+      </p:sp>
+      <p:sp>
+        <p:nvSpPr>
+          <p:cNvPr id="4" name="Slide Number Placeholder 3"/>
+          <p:cNvSpPr>
+            <a:spLocks noGrp="1"/>
+          </p:cNvSpPr>
+          <p:nvPr>
+            <p:ph type="sldNum" sz="quarter" idx="5"/>
+          </p:nvPr>
+        </p:nvSpPr>
+        <p:spPr/>
+        <p:txBody>
+          <a:bodyPr/>
+          <a:lstStyle/>
+          <a:p>
+            <a:fld id="{809340A9-5F99-47E5-A3AD-FD228EA849F8}" type="slidenum">
+              <a:rPr lang="en-GB" smtClean="0"/>
+              <a:t>17</a:t>
+            </a:fld>
+            <a:endParaRPr lang="en-GB"/>
+          </a:p>
+        </p:txBody>
+      </p:sp>
+    </p:spTree>
+    <p:extLst>
+      <p:ext uri="{BB962C8B-B14F-4D97-AF65-F5344CB8AC3E}">
+        <p14:creationId xmlns:p14="http://schemas.microsoft.com/office/powerpoint/2010/main" val="2013060265"/>
+      </p:ext>
+    </p:extLst>
+  </p:cSld>
+  <p:clrMapOvr>
+    <a:masterClrMapping/>
+  </p:clrMapOvr>
+</p:notes>
+</file>
+
 <file path=ppt/slideLayouts/slideLayout1.xml><?xml version="1.0" encoding="utf-8"?>
 <p:sldLayout xmlns:a="http://schemas.openxmlformats.org/drawingml/2006/main" xmlns:r="http://schemas.openxmlformats.org/officeDocument/2006/relationships" xmlns:p="http://schemas.openxmlformats.org/presentationml/2006/main" type="title" preserve="1">
   <p:cSld name="Title Slide">
@@ -2227,7 +2405,7 @@
           <a:p>
             <a:fld id="{BC38F1CC-ABF1-4C16-BBB2-7CC8083DBD41}" type="datetime1">
               <a:rPr lang="de-DE" smtClean="0"/>
-              <a:t>30.06.2025</a:t>
+              <a:t>01.07.2025</a:t>
             </a:fld>
             <a:endParaRPr lang="de-DE"/>
           </a:p>
@@ -2427,7 +2605,7 @@
           <a:p>
             <a:fld id="{5AD46073-F360-4B03-9A78-9F6E24BF38BF}" type="datetime1">
               <a:rPr lang="de-DE" smtClean="0"/>
-              <a:t>30.06.2025</a:t>
+              <a:t>01.07.2025</a:t>
             </a:fld>
             <a:endParaRPr lang="de-DE"/>
           </a:p>
@@ -2637,7 +2815,7 @@
           <a:p>
             <a:fld id="{60947668-F355-4DBF-B716-42DB1C64DFB7}" type="datetime1">
               <a:rPr lang="de-DE" smtClean="0"/>
-              <a:t>30.06.2025</a:t>
+              <a:t>01.07.2025</a:t>
             </a:fld>
             <a:endParaRPr lang="de-DE"/>
           </a:p>
@@ -2837,7 +3015,7 @@
           <a:p>
             <a:fld id="{CA09A6BA-2653-433C-BA9E-57AD9EE3A712}" type="datetime1">
               <a:rPr lang="de-DE" smtClean="0"/>
-              <a:t>30.06.2025</a:t>
+              <a:t>01.07.2025</a:t>
             </a:fld>
             <a:endParaRPr lang="de-DE"/>
           </a:p>
@@ -3113,7 +3291,7 @@
           <a:p>
             <a:fld id="{088226A6-5467-47C4-B46A-D1C4752B6C50}" type="datetime1">
               <a:rPr lang="de-DE" smtClean="0"/>
-              <a:t>30.06.2025</a:t>
+              <a:t>01.07.2025</a:t>
             </a:fld>
             <a:endParaRPr lang="de-DE"/>
           </a:p>
@@ -3381,7 +3559,7 @@
           <a:p>
             <a:fld id="{4DAD014D-DF7A-4A17-BE70-CBDCCD05F312}" type="datetime1">
               <a:rPr lang="de-DE" smtClean="0"/>
-              <a:t>30.06.2025</a:t>
+              <a:t>01.07.2025</a:t>
             </a:fld>
             <a:endParaRPr lang="de-DE"/>
           </a:p>
@@ -3796,7 +3974,7 @@
           <a:p>
             <a:fld id="{3DB58879-59D9-4DFD-ACCE-8F9DA76AC11D}" type="datetime1">
               <a:rPr lang="de-DE" smtClean="0"/>
-              <a:t>30.06.2025</a:t>
+              <a:t>01.07.2025</a:t>
             </a:fld>
             <a:endParaRPr lang="de-DE"/>
           </a:p>
@@ -3938,7 +4116,7 @@
           <a:p>
             <a:fld id="{1D668223-0355-4A47-87D8-E56CD5791C42}" type="datetime1">
               <a:rPr lang="de-DE" smtClean="0"/>
-              <a:t>30.06.2025</a:t>
+              <a:t>01.07.2025</a:t>
             </a:fld>
             <a:endParaRPr lang="de-DE"/>
           </a:p>
@@ -4051,7 +4229,7 @@
           <a:p>
             <a:fld id="{EC3C88DA-2725-48DA-8CAB-E21C779E0A52}" type="datetime1">
               <a:rPr lang="de-DE" smtClean="0"/>
-              <a:t>30.06.2025</a:t>
+              <a:t>01.07.2025</a:t>
             </a:fld>
             <a:endParaRPr lang="de-DE"/>
           </a:p>
@@ -4364,7 +4542,7 @@
           <a:p>
             <a:fld id="{F6DFF235-647B-4139-A6C7-FD3E9D31CB9A}" type="datetime1">
               <a:rPr lang="de-DE" smtClean="0"/>
-              <a:t>30.06.2025</a:t>
+              <a:t>01.07.2025</a:t>
             </a:fld>
             <a:endParaRPr lang="de-DE"/>
           </a:p>
@@ -4653,7 +4831,7 @@
           <a:p>
             <a:fld id="{7D1839DE-6FAF-4E43-BF2D-2423A301DC2E}" type="datetime1">
               <a:rPr lang="de-DE" smtClean="0"/>
-              <a:t>30.06.2025</a:t>
+              <a:t>01.07.2025</a:t>
             </a:fld>
             <a:endParaRPr lang="de-DE"/>
           </a:p>
@@ -4896,7 +5074,7 @@
           <a:p>
             <a:fld id="{CC0A0AA2-7FF6-400D-97F4-AF38EF94CB43}" type="datetime1">
               <a:rPr lang="de-DE" smtClean="0"/>
-              <a:t>30.06.2025</a:t>
+              <a:t>01.07.2025</a:t>
             </a:fld>
             <a:endParaRPr lang="de-DE"/>
           </a:p>
@@ -7067,6 +7245,321 @@
 </p:sld>
 </file>
 
+<file path=ppt/slides/slide16.xml><?xml version="1.0" encoding="utf-8"?>
+<p:sld xmlns:a="http://schemas.openxmlformats.org/drawingml/2006/main" xmlns:r="http://schemas.openxmlformats.org/officeDocument/2006/relationships" xmlns:p="http://schemas.openxmlformats.org/presentationml/2006/main">
+  <p:cSld>
+    <p:spTree>
+      <p:nvGrpSpPr>
+        <p:cNvPr id="1" name=""/>
+        <p:cNvGrpSpPr/>
+        <p:nvPr/>
+      </p:nvGrpSpPr>
+      <p:grpSpPr>
+        <a:xfrm>
+          <a:off x="0" y="0"/>
+          <a:ext cx="0" cy="0"/>
+          <a:chOff x="0" y="0"/>
+          <a:chExt cx="0" cy="0"/>
+        </a:xfrm>
+      </p:grpSpPr>
+      <p:sp>
+        <p:nvSpPr>
+          <p:cNvPr id="2" name="Title 1">
+            <a:extLst>
+              <a:ext uri="{FF2B5EF4-FFF2-40B4-BE49-F238E27FC236}">
+                <a16:creationId xmlns:a16="http://schemas.microsoft.com/office/drawing/2014/main" id="{5FB3238F-1ACA-C1E0-44A5-4EB3923A29C9}"/>
+              </a:ext>
+            </a:extLst>
+          </p:cNvPr>
+          <p:cNvSpPr>
+            <a:spLocks noGrp="1"/>
+          </p:cNvSpPr>
+          <p:nvPr>
+            <p:ph type="title"/>
+          </p:nvPr>
+        </p:nvSpPr>
+        <p:spPr/>
+        <p:txBody>
+          <a:bodyPr/>
+          <a:lstStyle/>
+          <a:p>
+            <a:r>
+              <a:rPr lang="en-US" dirty="0"/>
+              <a:t>Slide for the 0.18081 model in Kaggle</a:t>
+            </a:r>
+            <a:endParaRPr lang="en-GB" dirty="0"/>
+          </a:p>
+        </p:txBody>
+      </p:sp>
+      <p:sp>
+        <p:nvSpPr>
+          <p:cNvPr id="3" name="Content Placeholder 2">
+            <a:extLst>
+              <a:ext uri="{FF2B5EF4-FFF2-40B4-BE49-F238E27FC236}">
+                <a16:creationId xmlns:a16="http://schemas.microsoft.com/office/drawing/2014/main" id="{0815AB4C-65C2-DA76-D1CE-89CCEC02A309}"/>
+              </a:ext>
+            </a:extLst>
+          </p:cNvPr>
+          <p:cNvSpPr>
+            <a:spLocks noGrp="1"/>
+          </p:cNvSpPr>
+          <p:nvPr>
+            <p:ph sz="half" idx="1"/>
+          </p:nvPr>
+        </p:nvSpPr>
+        <p:spPr/>
+        <p:txBody>
+          <a:bodyPr/>
+          <a:lstStyle/>
+          <a:p>
+            <a:r>
+              <a:rPr lang="en-US" dirty="0"/>
+              <a:t>Add the Features I used</a:t>
+            </a:r>
+          </a:p>
+          <a:p>
+            <a:r>
+              <a:rPr lang="en-US" dirty="0"/>
+              <a:t>Model</a:t>
+            </a:r>
+          </a:p>
+          <a:p>
+            <a:r>
+              <a:rPr lang="en-US" dirty="0" err="1"/>
+              <a:t>Hyperparams</a:t>
+            </a:r>
+            <a:endParaRPr lang="en-US" dirty="0"/>
+          </a:p>
+          <a:p>
+            <a:r>
+              <a:rPr lang="en-US" dirty="0"/>
+              <a:t>Loss plot </a:t>
+            </a:r>
+          </a:p>
+          <a:p>
+            <a:r>
+              <a:rPr lang="en-US" dirty="0"/>
+              <a:t>MAPEs per prod group</a:t>
+            </a:r>
+          </a:p>
+        </p:txBody>
+      </p:sp>
+      <p:sp>
+        <p:nvSpPr>
+          <p:cNvPr id="4" name="Content Placeholder 3">
+            <a:extLst>
+              <a:ext uri="{FF2B5EF4-FFF2-40B4-BE49-F238E27FC236}">
+                <a16:creationId xmlns:a16="http://schemas.microsoft.com/office/drawing/2014/main" id="{46446D31-CD88-7EF2-2905-04B3365173EF}"/>
+              </a:ext>
+            </a:extLst>
+          </p:cNvPr>
+          <p:cNvSpPr>
+            <a:spLocks noGrp="1"/>
+          </p:cNvSpPr>
+          <p:nvPr>
+            <p:ph sz="half" idx="2"/>
+          </p:nvPr>
+        </p:nvSpPr>
+        <p:spPr/>
+        <p:txBody>
+          <a:bodyPr/>
+          <a:lstStyle/>
+          <a:p>
+            <a:endParaRPr lang="en-GB"/>
+          </a:p>
+        </p:txBody>
+      </p:sp>
+      <p:sp>
+        <p:nvSpPr>
+          <p:cNvPr id="5" name="Slide Number Placeholder 4">
+            <a:extLst>
+              <a:ext uri="{FF2B5EF4-FFF2-40B4-BE49-F238E27FC236}">
+                <a16:creationId xmlns:a16="http://schemas.microsoft.com/office/drawing/2014/main" id="{91904265-9121-893C-C8DF-6C777767E7D7}"/>
+              </a:ext>
+            </a:extLst>
+          </p:cNvPr>
+          <p:cNvSpPr>
+            <a:spLocks noGrp="1"/>
+          </p:cNvSpPr>
+          <p:nvPr>
+            <p:ph type="sldNum" sz="quarter" idx="12"/>
+          </p:nvPr>
+        </p:nvSpPr>
+        <p:spPr/>
+        <p:txBody>
+          <a:bodyPr/>
+          <a:lstStyle/>
+          <a:p>
+            <a:fld id="{FEE63D0E-FFEF-43D1-BE35-64C33AF422FD}" type="slidenum">
+              <a:rPr lang="de-DE" smtClean="0"/>
+              <a:t>16</a:t>
+            </a:fld>
+            <a:endParaRPr lang="de-DE"/>
+          </a:p>
+        </p:txBody>
+      </p:sp>
+    </p:spTree>
+    <p:extLst>
+      <p:ext uri="{BB962C8B-B14F-4D97-AF65-F5344CB8AC3E}">
+        <p14:creationId xmlns:p14="http://schemas.microsoft.com/office/powerpoint/2010/main" val="3404754989"/>
+      </p:ext>
+    </p:extLst>
+  </p:cSld>
+  <p:clrMapOvr>
+    <a:masterClrMapping/>
+  </p:clrMapOvr>
+</p:sld>
+</file>
+
+<file path=ppt/slides/slide17.xml><?xml version="1.0" encoding="utf-8"?>
+<p:sld xmlns:a="http://schemas.openxmlformats.org/drawingml/2006/main" xmlns:r="http://schemas.openxmlformats.org/officeDocument/2006/relationships" xmlns:p="http://schemas.openxmlformats.org/presentationml/2006/main">
+  <p:cSld>
+    <p:spTree>
+      <p:nvGrpSpPr>
+        <p:cNvPr id="1" name=""/>
+        <p:cNvGrpSpPr/>
+        <p:nvPr/>
+      </p:nvGrpSpPr>
+      <p:grpSpPr>
+        <a:xfrm>
+          <a:off x="0" y="0"/>
+          <a:ext cx="0" cy="0"/>
+          <a:chOff x="0" y="0"/>
+          <a:chExt cx="0" cy="0"/>
+        </a:xfrm>
+      </p:grpSpPr>
+      <p:sp>
+        <p:nvSpPr>
+          <p:cNvPr id="2" name="Title 1">
+            <a:extLst>
+              <a:ext uri="{FF2B5EF4-FFF2-40B4-BE49-F238E27FC236}">
+                <a16:creationId xmlns:a16="http://schemas.microsoft.com/office/drawing/2014/main" id="{29CF6418-DACC-03E6-70E9-910D55646865}"/>
+              </a:ext>
+            </a:extLst>
+          </p:cNvPr>
+          <p:cNvSpPr>
+            <a:spLocks noGrp="1"/>
+          </p:cNvSpPr>
+          <p:nvPr>
+            <p:ph type="title"/>
+          </p:nvPr>
+        </p:nvSpPr>
+        <p:spPr/>
+        <p:txBody>
+          <a:bodyPr/>
+          <a:lstStyle/>
+          <a:p>
+            <a:r>
+              <a:rPr lang="en-US" dirty="0"/>
+              <a:t>Challenges</a:t>
+            </a:r>
+            <a:endParaRPr lang="en-GB" dirty="0"/>
+          </a:p>
+        </p:txBody>
+      </p:sp>
+      <p:sp>
+        <p:nvSpPr>
+          <p:cNvPr id="3" name="Content Placeholder 2">
+            <a:extLst>
+              <a:ext uri="{FF2B5EF4-FFF2-40B4-BE49-F238E27FC236}">
+                <a16:creationId xmlns:a16="http://schemas.microsoft.com/office/drawing/2014/main" id="{E136724B-10E4-4F2B-608F-1474C2F84956}"/>
+              </a:ext>
+            </a:extLst>
+          </p:cNvPr>
+          <p:cNvSpPr>
+            <a:spLocks noGrp="1"/>
+          </p:cNvSpPr>
+          <p:nvPr>
+            <p:ph sz="half" idx="1"/>
+          </p:nvPr>
+        </p:nvSpPr>
+        <p:spPr>
+          <a:xfrm>
+            <a:off x="838199" y="1825625"/>
+            <a:ext cx="10023389" cy="4351338"/>
+          </a:xfrm>
+        </p:spPr>
+        <p:txBody>
+          <a:bodyPr/>
+          <a:lstStyle/>
+          <a:p>
+            <a:r>
+              <a:rPr lang="en-US" dirty="0"/>
+              <a:t>Select features</a:t>
+            </a:r>
+            <a:r>
+              <a:rPr lang="en-GB" dirty="0"/>
+              <a:t> &amp; Overfitting</a:t>
+            </a:r>
+          </a:p>
+          <a:p>
+            <a:endParaRPr lang="en-GB" dirty="0"/>
+          </a:p>
+          <a:p>
+            <a:r>
+              <a:rPr lang="en-GB" dirty="0"/>
+              <a:t>To Predict Group 5+ 6</a:t>
+            </a:r>
+          </a:p>
+          <a:p>
+            <a:endParaRPr lang="en-GB" dirty="0"/>
+          </a:p>
+          <a:p>
+            <a:r>
+              <a:rPr lang="en-GB" dirty="0"/>
+              <a:t>Biggest Improvement &gt; (maybe to remove variables that caused overfitting)</a:t>
+            </a:r>
+          </a:p>
+          <a:p>
+            <a:endParaRPr lang="en-GB" dirty="0"/>
+          </a:p>
+          <a:p>
+            <a:endParaRPr lang="en-US" dirty="0"/>
+          </a:p>
+        </p:txBody>
+      </p:sp>
+      <p:sp>
+        <p:nvSpPr>
+          <p:cNvPr id="5" name="Slide Number Placeholder 4">
+            <a:extLst>
+              <a:ext uri="{FF2B5EF4-FFF2-40B4-BE49-F238E27FC236}">
+                <a16:creationId xmlns:a16="http://schemas.microsoft.com/office/drawing/2014/main" id="{78B1F11F-D0B4-0880-8C7A-A219022B35E2}"/>
+              </a:ext>
+            </a:extLst>
+          </p:cNvPr>
+          <p:cNvSpPr>
+            <a:spLocks noGrp="1"/>
+          </p:cNvSpPr>
+          <p:nvPr>
+            <p:ph type="sldNum" sz="quarter" idx="12"/>
+          </p:nvPr>
+        </p:nvSpPr>
+        <p:spPr/>
+        <p:txBody>
+          <a:bodyPr/>
+          <a:lstStyle/>
+          <a:p>
+            <a:fld id="{FEE63D0E-FFEF-43D1-BE35-64C33AF422FD}" type="slidenum">
+              <a:rPr lang="de-DE" smtClean="0"/>
+              <a:t>17</a:t>
+            </a:fld>
+            <a:endParaRPr lang="de-DE"/>
+          </a:p>
+        </p:txBody>
+      </p:sp>
+    </p:spTree>
+    <p:extLst>
+      <p:ext uri="{BB962C8B-B14F-4D97-AF65-F5344CB8AC3E}">
+        <p14:creationId xmlns:p14="http://schemas.microsoft.com/office/powerpoint/2010/main" val="4069435508"/>
+      </p:ext>
+    </p:extLst>
+  </p:cSld>
+  <p:clrMapOvr>
+    <a:masterClrMapping/>
+  </p:clrMapOvr>
+</p:sld>
+</file>
+
 <file path=ppt/slides/slide2.xml><?xml version="1.0" encoding="utf-8"?>
 <p:sld xmlns:a="http://schemas.openxmlformats.org/drawingml/2006/main" xmlns:r="http://schemas.openxmlformats.org/officeDocument/2006/relationships" xmlns:p="http://schemas.openxmlformats.org/presentationml/2006/main">
   <p:cSld>
@@ -13851,8 +14344,8 @@
           </a:prstGeom>
         </p:spPr>
       </p:pic>
-      <mc:AlternateContent xmlns:mc="http://schemas.openxmlformats.org/markup-compatibility/2006">
-        <mc:Choice xmlns:p14="http://schemas.microsoft.com/office/powerpoint/2010/main" Requires="p14">
+      <mc:AlternateContent xmlns:mc="http://schemas.openxmlformats.org/markup-compatibility/2006" xmlns:p14="http://schemas.microsoft.com/office/powerpoint/2010/main">
+        <mc:Choice Requires="p14">
           <p:contentPart p14:bwMode="auto" r:id="rId4">
             <p14:nvContentPartPr>
               <p14:cNvPr id="15" name="Ink 14">
@@ -13871,7 +14364,7 @@
             </p14:xfrm>
           </p:contentPart>
         </mc:Choice>
-        <mc:Fallback>
+        <mc:Fallback xmlns="">
           <p:pic>
             <p:nvPicPr>
               <p:cNvPr id="15" name="Ink 14">
@@ -13902,8 +14395,8 @@
           </p:pic>
         </mc:Fallback>
       </mc:AlternateContent>
-      <mc:AlternateContent xmlns:mc="http://schemas.openxmlformats.org/markup-compatibility/2006">
-        <mc:Choice xmlns:p14="http://schemas.microsoft.com/office/powerpoint/2010/main" Requires="p14">
+      <mc:AlternateContent xmlns:mc="http://schemas.openxmlformats.org/markup-compatibility/2006" xmlns:p14="http://schemas.microsoft.com/office/powerpoint/2010/main">
+        <mc:Choice Requires="p14">
           <p:contentPart p14:bwMode="auto" r:id="rId6">
             <p14:nvContentPartPr>
               <p14:cNvPr id="16" name="Ink 15">
@@ -13922,7 +14415,7 @@
             </p14:xfrm>
           </p:contentPart>
         </mc:Choice>
-        <mc:Fallback>
+        <mc:Fallback xmlns="">
           <p:pic>
             <p:nvPicPr>
               <p:cNvPr id="16" name="Ink 15">
@@ -13953,8 +14446,8 @@
           </p:pic>
         </mc:Fallback>
       </mc:AlternateContent>
-      <mc:AlternateContent xmlns:mc="http://schemas.openxmlformats.org/markup-compatibility/2006">
-        <mc:Choice xmlns:p14="http://schemas.microsoft.com/office/powerpoint/2010/main" Requires="p14">
+      <mc:AlternateContent xmlns:mc="http://schemas.openxmlformats.org/markup-compatibility/2006" xmlns:p14="http://schemas.microsoft.com/office/powerpoint/2010/main">
+        <mc:Choice Requires="p14">
           <p:contentPart p14:bwMode="auto" r:id="rId8">
             <p14:nvContentPartPr>
               <p14:cNvPr id="18" name="Ink 17">
@@ -13973,7 +14466,7 @@
             </p14:xfrm>
           </p:contentPart>
         </mc:Choice>
-        <mc:Fallback>
+        <mc:Fallback xmlns="">
           <p:pic>
             <p:nvPicPr>
               <p:cNvPr id="18" name="Ink 17">
@@ -14004,8 +14497,8 @@
           </p:pic>
         </mc:Fallback>
       </mc:AlternateContent>
-      <mc:AlternateContent xmlns:mc="http://schemas.openxmlformats.org/markup-compatibility/2006">
-        <mc:Choice xmlns:p14="http://schemas.microsoft.com/office/powerpoint/2010/main" Requires="p14">
+      <mc:AlternateContent xmlns:mc="http://schemas.openxmlformats.org/markup-compatibility/2006" xmlns:p14="http://schemas.microsoft.com/office/powerpoint/2010/main">
+        <mc:Choice Requires="p14">
           <p:contentPart p14:bwMode="auto" r:id="rId10">
             <p14:nvContentPartPr>
               <p14:cNvPr id="19" name="Ink 18">
@@ -14024,7 +14517,7 @@
             </p14:xfrm>
           </p:contentPart>
         </mc:Choice>
-        <mc:Fallback>
+        <mc:Fallback xmlns="">
           <p:pic>
             <p:nvPicPr>
               <p:cNvPr id="19" name="Ink 18">
@@ -14055,8 +14548,8 @@
           </p:pic>
         </mc:Fallback>
       </mc:AlternateContent>
-      <mc:AlternateContent xmlns:mc="http://schemas.openxmlformats.org/markup-compatibility/2006">
-        <mc:Choice xmlns:p14="http://schemas.microsoft.com/office/powerpoint/2010/main" Requires="p14">
+      <mc:AlternateContent xmlns:mc="http://schemas.openxmlformats.org/markup-compatibility/2006" xmlns:p14="http://schemas.microsoft.com/office/powerpoint/2010/main">
+        <mc:Choice Requires="p14">
           <p:contentPart p14:bwMode="auto" r:id="rId12">
             <p14:nvContentPartPr>
               <p14:cNvPr id="20" name="Ink 19">
@@ -14075,7 +14568,7 @@
             </p14:xfrm>
           </p:contentPart>
         </mc:Choice>
-        <mc:Fallback>
+        <mc:Fallback xmlns="">
           <p:pic>
             <p:nvPicPr>
               <p:cNvPr id="20" name="Ink 19">
@@ -14106,8 +14599,8 @@
           </p:pic>
         </mc:Fallback>
       </mc:AlternateContent>
-      <mc:AlternateContent xmlns:mc="http://schemas.openxmlformats.org/markup-compatibility/2006">
-        <mc:Choice xmlns:p14="http://schemas.microsoft.com/office/powerpoint/2010/main" Requires="p14">
+      <mc:AlternateContent xmlns:mc="http://schemas.openxmlformats.org/markup-compatibility/2006" xmlns:p14="http://schemas.microsoft.com/office/powerpoint/2010/main">
+        <mc:Choice Requires="p14">
           <p:contentPart p14:bwMode="auto" r:id="rId14">
             <p14:nvContentPartPr>
               <p14:cNvPr id="21" name="Ink 20">
@@ -14126,7 +14619,7 @@
             </p14:xfrm>
           </p:contentPart>
         </mc:Choice>
-        <mc:Fallback>
+        <mc:Fallback xmlns="">
           <p:pic>
             <p:nvPicPr>
               <p:cNvPr id="21" name="Ink 20">
@@ -14157,8 +14650,8 @@
           </p:pic>
         </mc:Fallback>
       </mc:AlternateContent>
-      <mc:AlternateContent xmlns:mc="http://schemas.openxmlformats.org/markup-compatibility/2006">
-        <mc:Choice xmlns:p14="http://schemas.microsoft.com/office/powerpoint/2010/main" Requires="p14">
+      <mc:AlternateContent xmlns:mc="http://schemas.openxmlformats.org/markup-compatibility/2006" xmlns:p14="http://schemas.microsoft.com/office/powerpoint/2010/main">
+        <mc:Choice Requires="p14">
           <p:contentPart p14:bwMode="auto" r:id="rId16">
             <p14:nvContentPartPr>
               <p14:cNvPr id="22" name="Ink 21">
@@ -14177,7 +14670,7 @@
             </p14:xfrm>
           </p:contentPart>
         </mc:Choice>
-        <mc:Fallback>
+        <mc:Fallback xmlns="">
           <p:pic>
             <p:nvPicPr>
               <p:cNvPr id="22" name="Ink 21">
@@ -14384,8 +14877,8 @@
           </a:prstGeom>
         </p:spPr>
       </p:pic>
-      <mc:AlternateContent xmlns:mc="http://schemas.openxmlformats.org/markup-compatibility/2006">
-        <mc:Choice xmlns:p14="http://schemas.microsoft.com/office/powerpoint/2010/main" Requires="p14">
+      <mc:AlternateContent xmlns:mc="http://schemas.openxmlformats.org/markup-compatibility/2006" xmlns:p14="http://schemas.microsoft.com/office/powerpoint/2010/main">
+        <mc:Choice Requires="p14">
           <p:contentPart p14:bwMode="auto" r:id="rId20">
             <p14:nvContentPartPr>
               <p14:cNvPr id="24" name="Ink 23">
@@ -14404,7 +14897,7 @@
             </p14:xfrm>
           </p:contentPart>
         </mc:Choice>
-        <mc:Fallback>
+        <mc:Fallback xmlns="">
           <p:pic>
             <p:nvPicPr>
               <p:cNvPr id="24" name="Ink 23">
@@ -14835,8 +15328,8 @@
           </a:prstGeom>
         </p:spPr>
       </p:pic>
-      <mc:AlternateContent xmlns:mc="http://schemas.openxmlformats.org/markup-compatibility/2006">
-        <mc:Choice xmlns:p14="http://schemas.microsoft.com/office/powerpoint/2010/main" Requires="p14">
+      <mc:AlternateContent xmlns:mc="http://schemas.openxmlformats.org/markup-compatibility/2006" xmlns:p14="http://schemas.microsoft.com/office/powerpoint/2010/main">
+        <mc:Choice Requires="p14">
           <p:contentPart p14:bwMode="auto" r:id="rId4">
             <p14:nvContentPartPr>
               <p14:cNvPr id="15" name="Ink 14">
@@ -14855,7 +15348,7 @@
             </p14:xfrm>
           </p:contentPart>
         </mc:Choice>
-        <mc:Fallback>
+        <mc:Fallback xmlns="">
           <p:pic>
             <p:nvPicPr>
               <p:cNvPr id="15" name="Ink 14">
@@ -14886,8 +15379,8 @@
           </p:pic>
         </mc:Fallback>
       </mc:AlternateContent>
-      <mc:AlternateContent xmlns:mc="http://schemas.openxmlformats.org/markup-compatibility/2006">
-        <mc:Choice xmlns:p14="http://schemas.microsoft.com/office/powerpoint/2010/main" Requires="p14">
+      <mc:AlternateContent xmlns:mc="http://schemas.openxmlformats.org/markup-compatibility/2006" xmlns:p14="http://schemas.microsoft.com/office/powerpoint/2010/main">
+        <mc:Choice Requires="p14">
           <p:contentPart p14:bwMode="auto" r:id="rId6">
             <p14:nvContentPartPr>
               <p14:cNvPr id="16" name="Ink 15">
@@ -14906,7 +15399,7 @@
             </p14:xfrm>
           </p:contentPart>
         </mc:Choice>
-        <mc:Fallback>
+        <mc:Fallback xmlns="">
           <p:pic>
             <p:nvPicPr>
               <p:cNvPr id="16" name="Ink 15">
@@ -14937,8 +15430,8 @@
           </p:pic>
         </mc:Fallback>
       </mc:AlternateContent>
-      <mc:AlternateContent xmlns:mc="http://schemas.openxmlformats.org/markup-compatibility/2006">
-        <mc:Choice xmlns:p14="http://schemas.microsoft.com/office/powerpoint/2010/main" Requires="p14">
+      <mc:AlternateContent xmlns:mc="http://schemas.openxmlformats.org/markup-compatibility/2006" xmlns:p14="http://schemas.microsoft.com/office/powerpoint/2010/main">
+        <mc:Choice Requires="p14">
           <p:contentPart p14:bwMode="auto" r:id="rId8">
             <p14:nvContentPartPr>
               <p14:cNvPr id="18" name="Ink 17">
@@ -14957,7 +15450,7 @@
             </p14:xfrm>
           </p:contentPart>
         </mc:Choice>
-        <mc:Fallback>
+        <mc:Fallback xmlns="">
           <p:pic>
             <p:nvPicPr>
               <p:cNvPr id="18" name="Ink 17">
@@ -14988,8 +15481,8 @@
           </p:pic>
         </mc:Fallback>
       </mc:AlternateContent>
-      <mc:AlternateContent xmlns:mc="http://schemas.openxmlformats.org/markup-compatibility/2006">
-        <mc:Choice xmlns:p14="http://schemas.microsoft.com/office/powerpoint/2010/main" Requires="p14">
+      <mc:AlternateContent xmlns:mc="http://schemas.openxmlformats.org/markup-compatibility/2006" xmlns:p14="http://schemas.microsoft.com/office/powerpoint/2010/main">
+        <mc:Choice Requires="p14">
           <p:contentPart p14:bwMode="auto" r:id="rId10">
             <p14:nvContentPartPr>
               <p14:cNvPr id="19" name="Ink 18">
@@ -15008,7 +15501,7 @@
             </p14:xfrm>
           </p:contentPart>
         </mc:Choice>
-        <mc:Fallback>
+        <mc:Fallback xmlns="">
           <p:pic>
             <p:nvPicPr>
               <p:cNvPr id="19" name="Ink 18">
@@ -15039,8 +15532,8 @@
           </p:pic>
         </mc:Fallback>
       </mc:AlternateContent>
-      <mc:AlternateContent xmlns:mc="http://schemas.openxmlformats.org/markup-compatibility/2006">
-        <mc:Choice xmlns:p14="http://schemas.microsoft.com/office/powerpoint/2010/main" Requires="p14">
+      <mc:AlternateContent xmlns:mc="http://schemas.openxmlformats.org/markup-compatibility/2006" xmlns:p14="http://schemas.microsoft.com/office/powerpoint/2010/main">
+        <mc:Choice Requires="p14">
           <p:contentPart p14:bwMode="auto" r:id="rId12">
             <p14:nvContentPartPr>
               <p14:cNvPr id="20" name="Ink 19">
@@ -15059,7 +15552,7 @@
             </p14:xfrm>
           </p:contentPart>
         </mc:Choice>
-        <mc:Fallback>
+        <mc:Fallback xmlns="">
           <p:pic>
             <p:nvPicPr>
               <p:cNvPr id="20" name="Ink 19">
@@ -15090,8 +15583,8 @@
           </p:pic>
         </mc:Fallback>
       </mc:AlternateContent>
-      <mc:AlternateContent xmlns:mc="http://schemas.openxmlformats.org/markup-compatibility/2006">
-        <mc:Choice xmlns:p14="http://schemas.microsoft.com/office/powerpoint/2010/main" Requires="p14">
+      <mc:AlternateContent xmlns:mc="http://schemas.openxmlformats.org/markup-compatibility/2006" xmlns:p14="http://schemas.microsoft.com/office/powerpoint/2010/main">
+        <mc:Choice Requires="p14">
           <p:contentPart p14:bwMode="auto" r:id="rId14">
             <p14:nvContentPartPr>
               <p14:cNvPr id="21" name="Ink 20">
@@ -15110,7 +15603,7 @@
             </p14:xfrm>
           </p:contentPart>
         </mc:Choice>
-        <mc:Fallback>
+        <mc:Fallback xmlns="">
           <p:pic>
             <p:nvPicPr>
               <p:cNvPr id="21" name="Ink 20">
@@ -15141,8 +15634,8 @@
           </p:pic>
         </mc:Fallback>
       </mc:AlternateContent>
-      <mc:AlternateContent xmlns:mc="http://schemas.openxmlformats.org/markup-compatibility/2006">
-        <mc:Choice xmlns:p14="http://schemas.microsoft.com/office/powerpoint/2010/main" Requires="p14">
+      <mc:AlternateContent xmlns:mc="http://schemas.openxmlformats.org/markup-compatibility/2006" xmlns:p14="http://schemas.microsoft.com/office/powerpoint/2010/main">
+        <mc:Choice Requires="p14">
           <p:contentPart p14:bwMode="auto" r:id="rId16">
             <p14:nvContentPartPr>
               <p14:cNvPr id="22" name="Ink 21">
@@ -15161,7 +15654,7 @@
             </p14:xfrm>
           </p:contentPart>
         </mc:Choice>
-        <mc:Fallback>
+        <mc:Fallback xmlns="">
           <p:pic>
             <p:nvPicPr>
               <p:cNvPr id="22" name="Ink 21">

</xml_diff>